<commit_message>
Add ResNet18 transfer learning extension with real results
</commit_message>
<xml_diff>
--- a/presentation.pptx
+++ b/presentation.pptx
@@ -1272,7 +1272,68 @@
       </p:sp>
       <p:sp>
         <p:nvSpPr>
-          <p:cNvPr id="3" name="Text 1"/>
+          <p:cNvPr id="3" name="Shape 1"/>
+          <p:cNvSpPr/>
+          <p:nvPr/>
+        </p:nvSpPr>
+        <p:spPr>
+          <a:xfrm>
+            <a:off x="9189720" y="658368"/>
+            <a:ext cx="2377440" cy="475488"/>
+          </a:xfrm>
+          <a:prstGeom prst="roundRect">
+            <a:avLst>
+              <a:gd name="adj" fmla="val 50000"/>
+            </a:avLst>
+          </a:prstGeom>
+          <a:solidFill>
+            <a:srgbClr val="6096E6"/>
+          </a:solidFill>
+          <a:ln/>
+        </p:spPr>
+      </p:sp>
+      <p:sp>
+        <p:nvSpPr>
+          <p:cNvPr id="4" name="Text 2"/>
+          <p:cNvSpPr/>
+          <p:nvPr/>
+        </p:nvSpPr>
+        <p:spPr>
+          <a:xfrm>
+            <a:off x="9189720" y="658368"/>
+            <a:ext cx="2377440" cy="475488"/>
+          </a:xfrm>
+          <a:prstGeom prst="rect">
+            <a:avLst/>
+          </a:prstGeom>
+          <a:noFill/>
+          <a:ln/>
+        </p:spPr>
+        <p:txBody>
+          <a:bodyPr wrap="square" rtlCol="0" anchor="ctr"/>
+          <a:lstStyle/>
+          <a:p>
+            <a:pPr algn="ctr" indent="0" marL="0">
+              <a:buNone/>
+            </a:pPr>
+            <a:r>
+              <a:rPr lang="en-US" sz="1400" b="1" dirty="0">
+                <a:solidFill>
+                  <a:srgbClr val="FFFFFF"/>
+                </a:solidFill>
+                <a:latin typeface="微软雅黑" pitchFamily="34" charset="0"/>
+                <a:ea typeface="微软雅黑" pitchFamily="34" charset="-122"/>
+                <a:cs typeface="微软雅黑" pitchFamily="34" charset="-120"/>
+              </a:rPr>
+              <a:t>含自主扩展</a:t>
+            </a:r>
+            <a:endParaRPr lang="en-US" sz="1400" dirty="0"/>
+          </a:p>
+        </p:txBody>
+      </p:sp>
+      <p:sp>
+        <p:nvSpPr>
+          <p:cNvPr id="5" name="Text 3"/>
           <p:cNvSpPr/>
           <p:nvPr/>
         </p:nvSpPr>
@@ -1311,7 +1372,7 @@
       </p:sp>
       <p:sp>
         <p:nvSpPr>
-          <p:cNvPr id="4" name="Text 2"/>
+          <p:cNvPr id="6" name="Text 4"/>
           <p:cNvSpPr/>
           <p:nvPr/>
         </p:nvSpPr>
@@ -1350,7 +1411,7 @@
       </p:sp>
       <p:sp>
         <p:nvSpPr>
-          <p:cNvPr id="5" name="Text 3"/>
+          <p:cNvPr id="7" name="Text 5"/>
           <p:cNvSpPr/>
           <p:nvPr/>
         </p:nvSpPr>
@@ -1389,7 +1450,7 @@
       </p:sp>
       <p:sp>
         <p:nvSpPr>
-          <p:cNvPr id="6" name="Shape 4"/>
+          <p:cNvPr id="8" name="Shape 6"/>
           <p:cNvSpPr/>
           <p:nvPr/>
         </p:nvSpPr>
@@ -1416,7 +1477,7 @@
       </p:sp>
       <p:sp>
         <p:nvSpPr>
-          <p:cNvPr id="7" name="Text 5"/>
+          <p:cNvPr id="9" name="Text 7"/>
           <p:cNvSpPr/>
           <p:nvPr/>
         </p:nvSpPr>
@@ -1455,7 +1516,7 @@
       </p:sp>
       <p:sp>
         <p:nvSpPr>
-          <p:cNvPr id="8" name="Text 6"/>
+          <p:cNvPr id="10" name="Text 8"/>
           <p:cNvSpPr/>
           <p:nvPr/>
         </p:nvSpPr>
@@ -1494,7 +1555,7 @@
       </p:sp>
       <p:sp>
         <p:nvSpPr>
-          <p:cNvPr id="9" name="Shape 7"/>
+          <p:cNvPr id="11" name="Shape 9"/>
           <p:cNvSpPr/>
           <p:nvPr/>
         </p:nvSpPr>
@@ -1521,7 +1582,7 @@
       </p:sp>
       <p:sp>
         <p:nvSpPr>
-          <p:cNvPr id="10" name="Text 8"/>
+          <p:cNvPr id="12" name="Text 10"/>
           <p:cNvSpPr/>
           <p:nvPr/>
         </p:nvSpPr>
@@ -1560,7 +1621,7 @@
       </p:sp>
       <p:sp>
         <p:nvSpPr>
-          <p:cNvPr id="11" name="Text 9"/>
+          <p:cNvPr id="13" name="Text 11"/>
           <p:cNvSpPr/>
           <p:nvPr/>
         </p:nvSpPr>
@@ -1599,7 +1660,7 @@
       </p:sp>
       <p:sp>
         <p:nvSpPr>
-          <p:cNvPr id="12" name="Shape 10"/>
+          <p:cNvPr id="14" name="Shape 12"/>
           <p:cNvSpPr/>
           <p:nvPr/>
         </p:nvSpPr>
@@ -1626,7 +1687,7 @@
       </p:sp>
       <p:sp>
         <p:nvSpPr>
-          <p:cNvPr id="13" name="Text 11"/>
+          <p:cNvPr id="15" name="Text 13"/>
           <p:cNvSpPr/>
           <p:nvPr/>
         </p:nvSpPr>
@@ -1665,7 +1726,7 @@
       </p:sp>
       <p:sp>
         <p:nvSpPr>
-          <p:cNvPr id="14" name="Text 12"/>
+          <p:cNvPr id="16" name="Text 14"/>
           <p:cNvSpPr/>
           <p:nvPr/>
         </p:nvSpPr>
@@ -1704,7 +1765,7 @@
       </p:sp>
       <p:sp>
         <p:nvSpPr>
-          <p:cNvPr id="15" name="Shape 13"/>
+          <p:cNvPr id="17" name="Shape 15"/>
           <p:cNvSpPr/>
           <p:nvPr/>
         </p:nvSpPr>
@@ -1731,7 +1792,7 @@
       </p:sp>
       <p:pic>
         <p:nvPicPr>
-          <p:cNvPr id="16" name="Image 0" descr="C:/Users/蔡焕新/Documents/GitHub/mikuday0/student-work/day-02-concrete/data/raw/Positive/15704_1.jpg">    </p:cNvPr>
+          <p:cNvPr id="18" name="Image 0" descr="C:/Users/蔡焕新/Documents/GitHub/mikuday0/student-work/day-02-concrete/data/raw/Positive/15704_1.jpg">    </p:cNvPr>
           <p:cNvPicPr>
             <a:picLocks noChangeAspect="1"/>
           </p:cNvPicPr>
@@ -1755,7 +1816,7 @@
       </p:pic>
       <p:sp>
         <p:nvSpPr>
-          <p:cNvPr id="17" name="Text 14"/>
+          <p:cNvPr id="19" name="Text 16"/>
           <p:cNvSpPr/>
           <p:nvPr/>
         </p:nvSpPr>
@@ -2762,7 +2823,21 @@
                 <a:ea typeface="微软雅黑" pitchFamily="34" charset="-122"/>
                 <a:cs typeface="微软雅黑" pitchFamily="34" charset="-120"/>
               </a:rPr>
-              <a:t>同数据、同 75/25 划分（seed 2026：训练 900 / 测试 300）、同指标——只有模型不同，比较才公平</a:t>
+              <a:t>课程要求：同数据、同划分（seed 2026：训练 900 / 测试 300）、同指标——比较才公平</a:t>
+            </a:r>
+            <a:pPr algn="ctr" indent="0" marL="0">
+              <a:buNone/>
+            </a:pPr>
+            <a:r>
+              <a:rPr lang="en-US" sz="1300" b="1" dirty="0">
+                <a:solidFill>
+                  <a:srgbClr val="6096E6"/>
+                </a:solidFill>
+                <a:latin typeface="微软雅黑" pitchFamily="34" charset="0"/>
+                <a:ea typeface="微软雅黑" pitchFamily="34" charset="-122"/>
+                <a:cs typeface="微软雅黑" pitchFamily="34" charset="-120"/>
+              </a:rPr>
+              <a:t>　｜　自主扩展：ResNet18 迁移学习 + 消融 + 漏检优先阈值（见第 4 页）</a:t>
             </a:r>
             <a:endParaRPr lang="en-US" sz="1300" dirty="0"/>
           </a:p>
@@ -2833,7 +2908,7 @@
                 <a:ea typeface="微软雅黑" pitchFamily="34" charset="-122"/>
                 <a:cs typeface="微软雅黑" pitchFamily="34" charset="-120"/>
               </a:rPr>
-              <a:t>最重要证据：同一测试集的同条件比较</a:t>
+              <a:t>最重要证据：五个模型的同条件比较</a:t>
             </a:r>
             <a:endParaRPr lang="en-US" sz="2800" dirty="0"/>
           </a:p>
@@ -2872,7 +2947,7 @@
                 <a:ea typeface="微软雅黑" pitchFamily="34" charset="-122"/>
                 <a:cs typeface="微软雅黑" pitchFamily="34" charset="-120"/>
               </a:rPr>
-              <a:t>300 张留出测试图，seed 2026，每类取 600 张</a:t>
+              <a:t>同一 300 张留出测试图，seed 2026；浅蓝行 = 自主扩展（迁移学习 · 消融 · 漏检优先阈值），白行 = 课程要求内容</a:t>
             </a:r>
             <a:endParaRPr lang="en-US" sz="1400" dirty="0"/>
           </a:p>
@@ -2893,8 +2968,8 @@
           </p:nvPr>
         </p:nvGraphicFramePr>
         <p:xfrm>
-          <a:off x="548640" y="1371600"/>
-          <a:ext cx="5852160" cy="914400"/>
+          <a:off x="548640" y="1298448"/>
+          <a:ext cx="11155680" cy="914400"/>
         </p:xfrm>
         <a:graphic>
           <a:graphicData uri="http://schemas.openxmlformats.org/drawingml/2006/table">
@@ -2902,10 +2977,13 @@
               <a:tblPr/>
               <a:tblGrid>
                 <a:gridCol w="2926080"/>
-                <a:gridCol w="1463040"/>
-                <a:gridCol w="1463040"/>
+                <a:gridCol w="1645920"/>
+                <a:gridCol w="1645920"/>
+                <a:gridCol w="1645920"/>
+                <a:gridCol w="1645920"/>
+                <a:gridCol w="1645920"/>
               </a:tblGrid>
-              <a:tr h="475488">
+              <a:tr h="457200">
                 <a:tc>
                   <a:txBody>
                     <a:bodyPr/>
@@ -2915,7 +2993,7 @@
                         <a:buNone/>
                       </a:pPr>
                       <a:r>
-                        <a:rPr lang="en-US" sz="1300" b="1" dirty="0">
+                        <a:rPr lang="en-US" sz="1250" b="1" dirty="0">
                           <a:solidFill>
                             <a:srgbClr val="FFFFFF"/>
                           </a:solidFill>
@@ -2923,9 +3001,9 @@
                           <a:ea typeface="微软雅黑" pitchFamily="34" charset="-122"/>
                           <a:cs typeface="微软雅黑" pitchFamily="34" charset="-120"/>
                         </a:rPr>
-                        <a:t>指标</a:t>
+                        <a:t>模型</a:t>
                       </a:r>
-                      <a:endParaRPr lang="en-US" sz="1300" dirty="0">
+                      <a:endParaRPr lang="en-US" sz="1250" dirty="0">
                         <a:latin typeface="微软雅黑" charset="0"/>
                         <a:ea typeface="微软雅黑" charset="0"/>
                         <a:cs typeface="微软雅黑" charset="0"/>
@@ -2983,7 +3061,7 @@
                         <a:buNone/>
                       </a:pPr>
                       <a:r>
-                        <a:rPr lang="en-US" sz="1300" b="1" dirty="0">
+                        <a:rPr lang="en-US" sz="1250" b="1" dirty="0">
                           <a:solidFill>
                             <a:srgbClr val="FFFFFF"/>
                           </a:solidFill>
@@ -2991,9 +3069,9 @@
                           <a:ea typeface="微软雅黑" pitchFamily="34" charset="-122"/>
                           <a:cs typeface="微软雅黑" pitchFamily="34" charset="-120"/>
                         </a:rPr>
-                        <a:t>基线（多数类）</a:t>
+                        <a:t>Accuracy</a:t>
                       </a:r>
-                      <a:endParaRPr lang="en-US" sz="1300" dirty="0">
+                      <a:endParaRPr lang="en-US" sz="1250" dirty="0">
                         <a:latin typeface="微软雅黑" charset="0"/>
                         <a:ea typeface="微软雅黑" charset="0"/>
                         <a:cs typeface="微软雅黑" charset="0"/>
@@ -3051,7 +3129,7 @@
                         <a:buNone/>
                       </a:pPr>
                       <a:r>
-                        <a:rPr lang="en-US" sz="1300" b="1" dirty="0">
+                        <a:rPr lang="en-US" sz="1250" b="1" dirty="0">
                           <a:solidFill>
                             <a:srgbClr val="FFFFFF"/>
                           </a:solidFill>
@@ -3059,77 +3137,7 @@
                           <a:ea typeface="微软雅黑" pitchFamily="34" charset="-122"/>
                           <a:cs typeface="微软雅黑" pitchFamily="34" charset="-120"/>
                         </a:rPr>
-                        <a:t>候选（SmallCNN）</a:t>
-                      </a:r>
-                      <a:endParaRPr lang="en-US" sz="1300" dirty="0">
-                        <a:latin typeface="微软雅黑" charset="0"/>
-                        <a:ea typeface="微软雅黑" charset="0"/>
-                        <a:cs typeface="微软雅黑" charset="0"/>
-                      </a:endParaRPr>
-                    </a:p>
-                  </a:txBody>
-                  <a:tcPr marL="91440" marR="91440" marT="45720" marB="45720" anchor="ctr">
-                    <a:lnL w="9525" cap="flat" cmpd="sng" algn="ctr">
-                      <a:solidFill>
-                        <a:srgbClr val="D9E2EE"/>
-                      </a:solidFill>
-                      <a:prstDash val="solid"/>
-                      <a:round/>
-                      <a:headEnd type="none" w="med" len="med"/>
-                      <a:tailEnd type="none" w="med" len="med"/>
-                    </a:lnL>
-                    <a:lnR w="9525" cap="flat" cmpd="sng" algn="ctr">
-                      <a:solidFill>
-                        <a:srgbClr val="D9E2EE"/>
-                      </a:solidFill>
-                      <a:prstDash val="solid"/>
-                      <a:round/>
-                      <a:headEnd type="none" w="med" len="med"/>
-                      <a:tailEnd type="none" w="med" len="med"/>
-                    </a:lnR>
-                    <a:lnT w="9525" cap="flat" cmpd="sng" algn="ctr">
-                      <a:solidFill>
-                        <a:srgbClr val="D9E2EE"/>
-                      </a:solidFill>
-                      <a:prstDash val="solid"/>
-                      <a:round/>
-                      <a:headEnd type="none" w="med" len="med"/>
-                      <a:tailEnd type="none" w="med" len="med"/>
-                    </a:lnT>
-                    <a:lnB w="9525" cap="flat" cmpd="sng" algn="ctr">
-                      <a:solidFill>
-                        <a:srgbClr val="D9E2EE"/>
-                      </a:solidFill>
-                      <a:prstDash val="solid"/>
-                      <a:round/>
-                      <a:headEnd type="none" w="med" len="med"/>
-                      <a:tailEnd type="none" w="med" len="med"/>
-                    </a:lnB>
-                    <a:solidFill>
-                      <a:srgbClr val="0F1423"/>
-                    </a:solidFill>
-                  </a:tcPr>
-                </a:tc>
-              </a:tr>
-              <a:tr h="475488">
-                <a:tc>
-                  <a:txBody>
-                    <a:bodyPr/>
-                    <a:lstStyle/>
-                    <a:p>
-                      <a:pPr algn="ctr" indent="0" marL="0">
-                        <a:buNone/>
-                      </a:pPr>
-                      <a:r>
-                        <a:rPr lang="en-US" sz="1250" dirty="0">
-                          <a:solidFill>
-                            <a:srgbClr val="172A3A"/>
-                          </a:solidFill>
-                          <a:latin typeface="微软雅黑" pitchFamily="34" charset="0"/>
-                          <a:ea typeface="微软雅黑" pitchFamily="34" charset="-122"/>
-                          <a:cs typeface="微软雅黑" pitchFamily="34" charset="-120"/>
-                        </a:rPr>
-                        <a:t>accuracy 准确率</a:t>
+                        <a:t>Crack Precision</a:t>
                       </a:r>
                       <a:endParaRPr lang="en-US" sz="1250" dirty="0">
                         <a:latin typeface="微软雅黑" charset="0"/>
@@ -3175,71 +3183,9 @@
                       <a:headEnd type="none" w="med" len="med"/>
                       <a:tailEnd type="none" w="med" len="med"/>
                     </a:lnB>
-                  </a:tcPr>
-                </a:tc>
-                <a:tc>
-                  <a:txBody>
-                    <a:bodyPr/>
-                    <a:lstStyle/>
-                    <a:p>
-                      <a:pPr algn="ctr" indent="0" marL="0">
-                        <a:buNone/>
-                      </a:pPr>
-                      <a:r>
-                        <a:rPr lang="en-US" sz="1250" dirty="0">
-                          <a:solidFill>
-                            <a:srgbClr val="172A3A"/>
-                          </a:solidFill>
-                          <a:latin typeface="微软雅黑" pitchFamily="34" charset="0"/>
-                          <a:ea typeface="微软雅黑" pitchFamily="34" charset="-122"/>
-                          <a:cs typeface="微软雅黑" pitchFamily="34" charset="-120"/>
-                        </a:rPr>
-                        <a:t>0.500</a:t>
-                      </a:r>
-                      <a:endParaRPr lang="en-US" sz="1250" dirty="0">
-                        <a:latin typeface="微软雅黑" charset="0"/>
-                        <a:ea typeface="微软雅黑" charset="0"/>
-                        <a:cs typeface="微软雅黑" charset="0"/>
-                      </a:endParaRPr>
-                    </a:p>
-                  </a:txBody>
-                  <a:tcPr marL="91440" marR="91440" marT="45720" marB="45720" anchor="ctr">
-                    <a:lnL w="9525" cap="flat" cmpd="sng" algn="ctr">
-                      <a:solidFill>
-                        <a:srgbClr val="D9E2EE"/>
-                      </a:solidFill>
-                      <a:prstDash val="solid"/>
-                      <a:round/>
-                      <a:headEnd type="none" w="med" len="med"/>
-                      <a:tailEnd type="none" w="med" len="med"/>
-                    </a:lnL>
-                    <a:lnR w="9525" cap="flat" cmpd="sng" algn="ctr">
-                      <a:solidFill>
-                        <a:srgbClr val="D9E2EE"/>
-                      </a:solidFill>
-                      <a:prstDash val="solid"/>
-                      <a:round/>
-                      <a:headEnd type="none" w="med" len="med"/>
-                      <a:tailEnd type="none" w="med" len="med"/>
-                    </a:lnR>
-                    <a:lnT w="9525" cap="flat" cmpd="sng" algn="ctr">
-                      <a:solidFill>
-                        <a:srgbClr val="D9E2EE"/>
-                      </a:solidFill>
-                      <a:prstDash val="solid"/>
-                      <a:round/>
-                      <a:headEnd type="none" w="med" len="med"/>
-                      <a:tailEnd type="none" w="med" len="med"/>
-                    </a:lnT>
-                    <a:lnB w="9525" cap="flat" cmpd="sng" algn="ctr">
-                      <a:solidFill>
-                        <a:srgbClr val="D9E2EE"/>
-                      </a:solidFill>
-                      <a:prstDash val="solid"/>
-                      <a:round/>
-                      <a:headEnd type="none" w="med" len="med"/>
-                      <a:tailEnd type="none" w="med" len="med"/>
-                    </a:lnB>
+                    <a:solidFill>
+                      <a:srgbClr val="0F1423"/>
+                    </a:solidFill>
                   </a:tcPr>
                 </a:tc>
                 <a:tc>
@@ -3253,13 +3199,13 @@
                       <a:r>
                         <a:rPr lang="en-US" sz="1250" b="1" dirty="0">
                           <a:solidFill>
-                            <a:srgbClr val="56CA95"/>
+                            <a:srgbClr val="FFFFFF"/>
                           </a:solidFill>
                           <a:latin typeface="微软雅黑" pitchFamily="34" charset="0"/>
                           <a:ea typeface="微软雅黑" pitchFamily="34" charset="-122"/>
                           <a:cs typeface="微软雅黑" pitchFamily="34" charset="-120"/>
                         </a:rPr>
-                        <a:t>0.813</a:t>
+                        <a:t>Crack Recall</a:t>
                       </a:r>
                       <a:endParaRPr lang="en-US" sz="1250" dirty="0">
                         <a:latin typeface="微软雅黑" charset="0"/>
@@ -3305,138 +3251,9 @@
                       <a:headEnd type="none" w="med" len="med"/>
                       <a:tailEnd type="none" w="med" len="med"/>
                     </a:lnB>
-                  </a:tcPr>
-                </a:tc>
-              </a:tr>
-              <a:tr h="475488">
-                <a:tc>
-                  <a:txBody>
-                    <a:bodyPr/>
-                    <a:lstStyle/>
-                    <a:p>
-                      <a:pPr algn="ctr" indent="0" marL="0">
-                        <a:buNone/>
-                      </a:pPr>
-                      <a:r>
-                        <a:rPr lang="en-US" sz="1250" dirty="0">
-                          <a:solidFill>
-                            <a:srgbClr val="172A3A"/>
-                          </a:solidFill>
-                          <a:latin typeface="微软雅黑" pitchFamily="34" charset="0"/>
-                          <a:ea typeface="微软雅黑" pitchFamily="34" charset="-122"/>
-                          <a:cs typeface="微软雅黑" pitchFamily="34" charset="-120"/>
-                        </a:rPr>
-                        <a:t>recall_crack 裂缝召回率</a:t>
-                      </a:r>
-                      <a:endParaRPr lang="en-US" sz="1250" dirty="0">
-                        <a:latin typeface="微软雅黑" charset="0"/>
-                        <a:ea typeface="微软雅黑" charset="0"/>
-                        <a:cs typeface="微软雅黑" charset="0"/>
-                      </a:endParaRPr>
-                    </a:p>
-                  </a:txBody>
-                  <a:tcPr marL="91440" marR="91440" marT="45720" marB="45720" anchor="ctr">
-                    <a:lnL w="9525" cap="flat" cmpd="sng" algn="ctr">
-                      <a:solidFill>
-                        <a:srgbClr val="D9E2EE"/>
-                      </a:solidFill>
-                      <a:prstDash val="solid"/>
-                      <a:round/>
-                      <a:headEnd type="none" w="med" len="med"/>
-                      <a:tailEnd type="none" w="med" len="med"/>
-                    </a:lnL>
-                    <a:lnR w="9525" cap="flat" cmpd="sng" algn="ctr">
-                      <a:solidFill>
-                        <a:srgbClr val="D9E2EE"/>
-                      </a:solidFill>
-                      <a:prstDash val="solid"/>
-                      <a:round/>
-                      <a:headEnd type="none" w="med" len="med"/>
-                      <a:tailEnd type="none" w="med" len="med"/>
-                    </a:lnR>
-                    <a:lnT w="9525" cap="flat" cmpd="sng" algn="ctr">
-                      <a:solidFill>
-                        <a:srgbClr val="D9E2EE"/>
-                      </a:solidFill>
-                      <a:prstDash val="solid"/>
-                      <a:round/>
-                      <a:headEnd type="none" w="med" len="med"/>
-                      <a:tailEnd type="none" w="med" len="med"/>
-                    </a:lnT>
-                    <a:lnB w="9525" cap="flat" cmpd="sng" algn="ctr">
-                      <a:solidFill>
-                        <a:srgbClr val="D9E2EE"/>
-                      </a:solidFill>
-                      <a:prstDash val="solid"/>
-                      <a:round/>
-                      <a:headEnd type="none" w="med" len="med"/>
-                      <a:tailEnd type="none" w="med" len="med"/>
-                    </a:lnB>
-                  </a:tcPr>
-                </a:tc>
-                <a:tc>
-                  <a:txBody>
-                    <a:bodyPr/>
-                    <a:lstStyle/>
-                    <a:p>
-                      <a:pPr algn="ctr" indent="0" marL="0">
-                        <a:buNone/>
-                      </a:pPr>
-                      <a:r>
-                        <a:rPr lang="en-US" sz="1250" dirty="0">
-                          <a:solidFill>
-                            <a:srgbClr val="172A3A"/>
-                          </a:solidFill>
-                          <a:latin typeface="微软雅黑" pitchFamily="34" charset="0"/>
-                          <a:ea typeface="微软雅黑" pitchFamily="34" charset="-122"/>
-                          <a:cs typeface="微软雅黑" pitchFamily="34" charset="-120"/>
-                        </a:rPr>
-                        <a:t>1.000</a:t>
-                      </a:r>
-                      <a:endParaRPr lang="en-US" sz="1250" dirty="0">
-                        <a:latin typeface="微软雅黑" charset="0"/>
-                        <a:ea typeface="微软雅黑" charset="0"/>
-                        <a:cs typeface="微软雅黑" charset="0"/>
-                      </a:endParaRPr>
-                    </a:p>
-                  </a:txBody>
-                  <a:tcPr marL="91440" marR="91440" marT="45720" marB="45720" anchor="ctr">
-                    <a:lnL w="9525" cap="flat" cmpd="sng" algn="ctr">
-                      <a:solidFill>
-                        <a:srgbClr val="D9E2EE"/>
-                      </a:solidFill>
-                      <a:prstDash val="solid"/>
-                      <a:round/>
-                      <a:headEnd type="none" w="med" len="med"/>
-                      <a:tailEnd type="none" w="med" len="med"/>
-                    </a:lnL>
-                    <a:lnR w="9525" cap="flat" cmpd="sng" algn="ctr">
-                      <a:solidFill>
-                        <a:srgbClr val="D9E2EE"/>
-                      </a:solidFill>
-                      <a:prstDash val="solid"/>
-                      <a:round/>
-                      <a:headEnd type="none" w="med" len="med"/>
-                      <a:tailEnd type="none" w="med" len="med"/>
-                    </a:lnR>
-                    <a:lnT w="9525" cap="flat" cmpd="sng" algn="ctr">
-                      <a:solidFill>
-                        <a:srgbClr val="D9E2EE"/>
-                      </a:solidFill>
-                      <a:prstDash val="solid"/>
-                      <a:round/>
-                      <a:headEnd type="none" w="med" len="med"/>
-                      <a:tailEnd type="none" w="med" len="med"/>
-                    </a:lnT>
-                    <a:lnB w="9525" cap="flat" cmpd="sng" algn="ctr">
-                      <a:solidFill>
-                        <a:srgbClr val="D9E2EE"/>
-                      </a:solidFill>
-                      <a:prstDash val="solid"/>
-                      <a:round/>
-                      <a:headEnd type="none" w="med" len="med"/>
-                      <a:tailEnd type="none" w="med" len="med"/>
-                    </a:lnB>
+                    <a:solidFill>
+                      <a:srgbClr val="0F1423"/>
+                    </a:solidFill>
                   </a:tcPr>
                 </a:tc>
                 <a:tc>
@@ -3450,13 +3267,13 @@
                       <a:r>
                         <a:rPr lang="en-US" sz="1250" b="1" dirty="0">
                           <a:solidFill>
-                            <a:srgbClr val="56CA95"/>
+                            <a:srgbClr val="FFFFFF"/>
                           </a:solidFill>
                           <a:latin typeface="微软雅黑" pitchFamily="34" charset="0"/>
                           <a:ea typeface="微软雅黑" pitchFamily="34" charset="-122"/>
                           <a:cs typeface="微软雅黑" pitchFamily="34" charset="-120"/>
                         </a:rPr>
-                        <a:t>0.713</a:t>
+                        <a:t>FN 漏检</a:t>
                       </a:r>
                       <a:endParaRPr lang="en-US" sz="1250" dirty="0">
                         <a:latin typeface="微软雅黑" charset="0"/>
@@ -3502,335 +3319,9 @@
                       <a:headEnd type="none" w="med" len="med"/>
                       <a:tailEnd type="none" w="med" len="med"/>
                     </a:lnB>
-                  </a:tcPr>
-                </a:tc>
-              </a:tr>
-              <a:tr h="475488">
-                <a:tc>
-                  <a:txBody>
-                    <a:bodyPr/>
-                    <a:lstStyle/>
-                    <a:p>
-                      <a:pPr algn="ctr" indent="0" marL="0">
-                        <a:buNone/>
-                      </a:pPr>
-                      <a:r>
-                        <a:rPr lang="en-US" sz="1250" dirty="0">
-                          <a:solidFill>
-                            <a:srgbClr val="172A3A"/>
-                          </a:solidFill>
-                          <a:latin typeface="微软雅黑" pitchFamily="34" charset="0"/>
-                          <a:ea typeface="微软雅黑" pitchFamily="34" charset="-122"/>
-                          <a:cs typeface="微软雅黑" pitchFamily="34" charset="-120"/>
-                        </a:rPr>
-                        <a:t>precision_crack 裂缝精确率</a:t>
-                      </a:r>
-                      <a:endParaRPr lang="en-US" sz="1250" dirty="0">
-                        <a:latin typeface="微软雅黑" charset="0"/>
-                        <a:ea typeface="微软雅黑" charset="0"/>
-                        <a:cs typeface="微软雅黑" charset="0"/>
-                      </a:endParaRPr>
-                    </a:p>
-                  </a:txBody>
-                  <a:tcPr marL="91440" marR="91440" marT="45720" marB="45720" anchor="ctr">
-                    <a:lnL w="9525" cap="flat" cmpd="sng" algn="ctr">
-                      <a:solidFill>
-                        <a:srgbClr val="D9E2EE"/>
-                      </a:solidFill>
-                      <a:prstDash val="solid"/>
-                      <a:round/>
-                      <a:headEnd type="none" w="med" len="med"/>
-                      <a:tailEnd type="none" w="med" len="med"/>
-                    </a:lnL>
-                    <a:lnR w="9525" cap="flat" cmpd="sng" algn="ctr">
-                      <a:solidFill>
-                        <a:srgbClr val="D9E2EE"/>
-                      </a:solidFill>
-                      <a:prstDash val="solid"/>
-                      <a:round/>
-                      <a:headEnd type="none" w="med" len="med"/>
-                      <a:tailEnd type="none" w="med" len="med"/>
-                    </a:lnR>
-                    <a:lnT w="9525" cap="flat" cmpd="sng" algn="ctr">
-                      <a:solidFill>
-                        <a:srgbClr val="D9E2EE"/>
-                      </a:solidFill>
-                      <a:prstDash val="solid"/>
-                      <a:round/>
-                      <a:headEnd type="none" w="med" len="med"/>
-                      <a:tailEnd type="none" w="med" len="med"/>
-                    </a:lnT>
-                    <a:lnB w="9525" cap="flat" cmpd="sng" algn="ctr">
-                      <a:solidFill>
-                        <a:srgbClr val="D9E2EE"/>
-                      </a:solidFill>
-                      <a:prstDash val="solid"/>
-                      <a:round/>
-                      <a:headEnd type="none" w="med" len="med"/>
-                      <a:tailEnd type="none" w="med" len="med"/>
-                    </a:lnB>
-                  </a:tcPr>
-                </a:tc>
-                <a:tc>
-                  <a:txBody>
-                    <a:bodyPr/>
-                    <a:lstStyle/>
-                    <a:p>
-                      <a:pPr algn="ctr" indent="0" marL="0">
-                        <a:buNone/>
-                      </a:pPr>
-                      <a:r>
-                        <a:rPr lang="en-US" sz="1250" dirty="0">
-                          <a:solidFill>
-                            <a:srgbClr val="172A3A"/>
-                          </a:solidFill>
-                          <a:latin typeface="微软雅黑" pitchFamily="34" charset="0"/>
-                          <a:ea typeface="微软雅黑" pitchFamily="34" charset="-122"/>
-                          <a:cs typeface="微软雅黑" pitchFamily="34" charset="-120"/>
-                        </a:rPr>
-                        <a:t>0.500</a:t>
-                      </a:r>
-                      <a:endParaRPr lang="en-US" sz="1250" dirty="0">
-                        <a:latin typeface="微软雅黑" charset="0"/>
-                        <a:ea typeface="微软雅黑" charset="0"/>
-                        <a:cs typeface="微软雅黑" charset="0"/>
-                      </a:endParaRPr>
-                    </a:p>
-                  </a:txBody>
-                  <a:tcPr marL="91440" marR="91440" marT="45720" marB="45720" anchor="ctr">
-                    <a:lnL w="9525" cap="flat" cmpd="sng" algn="ctr">
-                      <a:solidFill>
-                        <a:srgbClr val="D9E2EE"/>
-                      </a:solidFill>
-                      <a:prstDash val="solid"/>
-                      <a:round/>
-                      <a:headEnd type="none" w="med" len="med"/>
-                      <a:tailEnd type="none" w="med" len="med"/>
-                    </a:lnL>
-                    <a:lnR w="9525" cap="flat" cmpd="sng" algn="ctr">
-                      <a:solidFill>
-                        <a:srgbClr val="D9E2EE"/>
-                      </a:solidFill>
-                      <a:prstDash val="solid"/>
-                      <a:round/>
-                      <a:headEnd type="none" w="med" len="med"/>
-                      <a:tailEnd type="none" w="med" len="med"/>
-                    </a:lnR>
-                    <a:lnT w="9525" cap="flat" cmpd="sng" algn="ctr">
-                      <a:solidFill>
-                        <a:srgbClr val="D9E2EE"/>
-                      </a:solidFill>
-                      <a:prstDash val="solid"/>
-                      <a:round/>
-                      <a:headEnd type="none" w="med" len="med"/>
-                      <a:tailEnd type="none" w="med" len="med"/>
-                    </a:lnT>
-                    <a:lnB w="9525" cap="flat" cmpd="sng" algn="ctr">
-                      <a:solidFill>
-                        <a:srgbClr val="D9E2EE"/>
-                      </a:solidFill>
-                      <a:prstDash val="solid"/>
-                      <a:round/>
-                      <a:headEnd type="none" w="med" len="med"/>
-                      <a:tailEnd type="none" w="med" len="med"/>
-                    </a:lnB>
-                  </a:tcPr>
-                </a:tc>
-                <a:tc>
-                  <a:txBody>
-                    <a:bodyPr/>
-                    <a:lstStyle/>
-                    <a:p>
-                      <a:pPr algn="ctr" indent="0" marL="0">
-                        <a:buNone/>
-                      </a:pPr>
-                      <a:r>
-                        <a:rPr lang="en-US" sz="1250" dirty="0">
-                          <a:solidFill>
-                            <a:srgbClr val="172A3A"/>
-                          </a:solidFill>
-                          <a:latin typeface="微软雅黑" pitchFamily="34" charset="0"/>
-                          <a:ea typeface="微软雅黑" pitchFamily="34" charset="-122"/>
-                          <a:cs typeface="微软雅黑" pitchFamily="34" charset="-120"/>
-                        </a:rPr>
-                        <a:t>0.892</a:t>
-                      </a:r>
-                      <a:endParaRPr lang="en-US" sz="1250" dirty="0">
-                        <a:latin typeface="微软雅黑" charset="0"/>
-                        <a:ea typeface="微软雅黑" charset="0"/>
-                        <a:cs typeface="微软雅黑" charset="0"/>
-                      </a:endParaRPr>
-                    </a:p>
-                  </a:txBody>
-                  <a:tcPr marL="91440" marR="91440" marT="45720" marB="45720" anchor="ctr">
-                    <a:lnL w="9525" cap="flat" cmpd="sng" algn="ctr">
-                      <a:solidFill>
-                        <a:srgbClr val="D9E2EE"/>
-                      </a:solidFill>
-                      <a:prstDash val="solid"/>
-                      <a:round/>
-                      <a:headEnd type="none" w="med" len="med"/>
-                      <a:tailEnd type="none" w="med" len="med"/>
-                    </a:lnL>
-                    <a:lnR w="9525" cap="flat" cmpd="sng" algn="ctr">
-                      <a:solidFill>
-                        <a:srgbClr val="D9E2EE"/>
-                      </a:solidFill>
-                      <a:prstDash val="solid"/>
-                      <a:round/>
-                      <a:headEnd type="none" w="med" len="med"/>
-                      <a:tailEnd type="none" w="med" len="med"/>
-                    </a:lnR>
-                    <a:lnT w="9525" cap="flat" cmpd="sng" algn="ctr">
-                      <a:solidFill>
-                        <a:srgbClr val="D9E2EE"/>
-                      </a:solidFill>
-                      <a:prstDash val="solid"/>
-                      <a:round/>
-                      <a:headEnd type="none" w="med" len="med"/>
-                      <a:tailEnd type="none" w="med" len="med"/>
-                    </a:lnT>
-                    <a:lnB w="9525" cap="flat" cmpd="sng" algn="ctr">
-                      <a:solidFill>
-                        <a:srgbClr val="D9E2EE"/>
-                      </a:solidFill>
-                      <a:prstDash val="solid"/>
-                      <a:round/>
-                      <a:headEnd type="none" w="med" len="med"/>
-                      <a:tailEnd type="none" w="med" len="med"/>
-                    </a:lnB>
-                  </a:tcPr>
-                </a:tc>
-              </a:tr>
-              <a:tr h="475488">
-                <a:tc>
-                  <a:txBody>
-                    <a:bodyPr/>
-                    <a:lstStyle/>
-                    <a:p>
-                      <a:pPr algn="ctr" indent="0" marL="0">
-                        <a:buNone/>
-                      </a:pPr>
-                      <a:r>
-                        <a:rPr lang="en-US" sz="1250" b="1" dirty="0">
-                          <a:solidFill>
-                            <a:srgbClr val="EC5F74"/>
-                          </a:solidFill>
-                          <a:latin typeface="微软雅黑" pitchFamily="34" charset="0"/>
-                          <a:ea typeface="微软雅黑" pitchFamily="34" charset="-122"/>
-                          <a:cs typeface="微软雅黑" pitchFamily="34" charset="-120"/>
-                        </a:rPr>
-                        <a:t>漏检裂缝（假阴性）</a:t>
-                      </a:r>
-                      <a:endParaRPr lang="en-US" sz="1250" dirty="0">
-                        <a:latin typeface="微软雅黑" charset="0"/>
-                        <a:ea typeface="微软雅黑" charset="0"/>
-                        <a:cs typeface="微软雅黑" charset="0"/>
-                      </a:endParaRPr>
-                    </a:p>
-                  </a:txBody>
-                  <a:tcPr marL="91440" marR="91440" marT="45720" marB="45720" anchor="ctr">
-                    <a:lnL w="9525" cap="flat" cmpd="sng" algn="ctr">
-                      <a:solidFill>
-                        <a:srgbClr val="D9E2EE"/>
-                      </a:solidFill>
-                      <a:prstDash val="solid"/>
-                      <a:round/>
-                      <a:headEnd type="none" w="med" len="med"/>
-                      <a:tailEnd type="none" w="med" len="med"/>
-                    </a:lnL>
-                    <a:lnR w="9525" cap="flat" cmpd="sng" algn="ctr">
-                      <a:solidFill>
-                        <a:srgbClr val="D9E2EE"/>
-                      </a:solidFill>
-                      <a:prstDash val="solid"/>
-                      <a:round/>
-                      <a:headEnd type="none" w="med" len="med"/>
-                      <a:tailEnd type="none" w="med" len="med"/>
-                    </a:lnR>
-                    <a:lnT w="9525" cap="flat" cmpd="sng" algn="ctr">
-                      <a:solidFill>
-                        <a:srgbClr val="D9E2EE"/>
-                      </a:solidFill>
-                      <a:prstDash val="solid"/>
-                      <a:round/>
-                      <a:headEnd type="none" w="med" len="med"/>
-                      <a:tailEnd type="none" w="med" len="med"/>
-                    </a:lnT>
-                    <a:lnB w="9525" cap="flat" cmpd="sng" algn="ctr">
-                      <a:solidFill>
-                        <a:srgbClr val="D9E2EE"/>
-                      </a:solidFill>
-                      <a:prstDash val="solid"/>
-                      <a:round/>
-                      <a:headEnd type="none" w="med" len="med"/>
-                      <a:tailEnd type="none" w="med" len="med"/>
-                    </a:lnB>
-                  </a:tcPr>
-                </a:tc>
-                <a:tc>
-                  <a:txBody>
-                    <a:bodyPr/>
-                    <a:lstStyle/>
-                    <a:p>
-                      <a:pPr algn="ctr" indent="0" marL="0">
-                        <a:buNone/>
-                      </a:pPr>
-                      <a:r>
-                        <a:rPr lang="en-US" sz="1250" dirty="0">
-                          <a:solidFill>
-                            <a:srgbClr val="172A3A"/>
-                          </a:solidFill>
-                          <a:latin typeface="微软雅黑" pitchFamily="34" charset="0"/>
-                          <a:ea typeface="微软雅黑" pitchFamily="34" charset="-122"/>
-                          <a:cs typeface="微软雅黑" pitchFamily="34" charset="-120"/>
-                        </a:rPr>
-                        <a:t>0</a:t>
-                      </a:r>
-                      <a:endParaRPr lang="en-US" sz="1250" dirty="0">
-                        <a:latin typeface="微软雅黑" charset="0"/>
-                        <a:ea typeface="微软雅黑" charset="0"/>
-                        <a:cs typeface="微软雅黑" charset="0"/>
-                      </a:endParaRPr>
-                    </a:p>
-                  </a:txBody>
-                  <a:tcPr marL="91440" marR="91440" marT="45720" marB="45720" anchor="ctr">
-                    <a:lnL w="9525" cap="flat" cmpd="sng" algn="ctr">
-                      <a:solidFill>
-                        <a:srgbClr val="D9E2EE"/>
-                      </a:solidFill>
-                      <a:prstDash val="solid"/>
-                      <a:round/>
-                      <a:headEnd type="none" w="med" len="med"/>
-                      <a:tailEnd type="none" w="med" len="med"/>
-                    </a:lnL>
-                    <a:lnR w="9525" cap="flat" cmpd="sng" algn="ctr">
-                      <a:solidFill>
-                        <a:srgbClr val="D9E2EE"/>
-                      </a:solidFill>
-                      <a:prstDash val="solid"/>
-                      <a:round/>
-                      <a:headEnd type="none" w="med" len="med"/>
-                      <a:tailEnd type="none" w="med" len="med"/>
-                    </a:lnR>
-                    <a:lnT w="9525" cap="flat" cmpd="sng" algn="ctr">
-                      <a:solidFill>
-                        <a:srgbClr val="D9E2EE"/>
-                      </a:solidFill>
-                      <a:prstDash val="solid"/>
-                      <a:round/>
-                      <a:headEnd type="none" w="med" len="med"/>
-                      <a:tailEnd type="none" w="med" len="med"/>
-                    </a:lnT>
-                    <a:lnB w="9525" cap="flat" cmpd="sng" algn="ctr">
-                      <a:solidFill>
-                        <a:srgbClr val="D9E2EE"/>
-                      </a:solidFill>
-                      <a:prstDash val="solid"/>
-                      <a:round/>
-                      <a:headEnd type="none" w="med" len="med"/>
-                      <a:tailEnd type="none" w="med" len="med"/>
-                    </a:lnB>
+                    <a:solidFill>
+                      <a:srgbClr val="0F1423"/>
+                    </a:solidFill>
                   </a:tcPr>
                 </a:tc>
                 <a:tc>
@@ -3844,13 +3335,13 @@
                       <a:r>
                         <a:rPr lang="en-US" sz="1250" b="1" dirty="0">
                           <a:solidFill>
-                            <a:srgbClr val="EC5F74"/>
+                            <a:srgbClr val="FFFFFF"/>
                           </a:solidFill>
                           <a:latin typeface="微软雅黑" pitchFamily="34" charset="0"/>
                           <a:ea typeface="微软雅黑" pitchFamily="34" charset="-122"/>
                           <a:cs typeface="微软雅黑" pitchFamily="34" charset="-120"/>
                         </a:rPr>
-                        <a:t>43</a:t>
+                        <a:t>FP 误报</a:t>
                       </a:r>
                       <a:endParaRPr lang="en-US" sz="1250" dirty="0">
                         <a:latin typeface="微软雅黑" charset="0"/>
@@ -3896,10 +3387,13 @@
                       <a:headEnd type="none" w="med" len="med"/>
                       <a:tailEnd type="none" w="med" len="med"/>
                     </a:lnB>
+                    <a:solidFill>
+                      <a:srgbClr val="0F1423"/>
+                    </a:solidFill>
                   </a:tcPr>
                 </a:tc>
               </a:tr>
-              <a:tr h="475488">
+              <a:tr h="457200">
                 <a:tc>
                   <a:txBody>
                     <a:bodyPr/>
@@ -3909,7 +3403,7 @@
                         <a:buNone/>
                       </a:pPr>
                       <a:r>
-                        <a:rPr lang="en-US" sz="1250" dirty="0">
+                        <a:rPr lang="en-US" sz="1200" dirty="0">
                           <a:solidFill>
                             <a:srgbClr val="172A3A"/>
                           </a:solidFill>
@@ -3917,9 +3411,9 @@
                           <a:ea typeface="微软雅黑" pitchFamily="34" charset="-122"/>
                           <a:cs typeface="微软雅黑" pitchFamily="34" charset="-120"/>
                         </a:rPr>
-                        <a:t>误报（假阳性）</a:t>
+                        <a:t>Majority baseline</a:t>
                       </a:r>
-                      <a:endParaRPr lang="en-US" sz="1250" dirty="0">
+                      <a:endParaRPr lang="en-US" sz="1200" dirty="0">
                         <a:latin typeface="微软雅黑" charset="0"/>
                         <a:ea typeface="微软雅黑" charset="0"/>
                         <a:cs typeface="微软雅黑" charset="0"/>
@@ -3974,7 +3468,7 @@
                         <a:buNone/>
                       </a:pPr>
                       <a:r>
-                        <a:rPr lang="en-US" sz="1250" dirty="0">
+                        <a:rPr lang="en-US" sz="1200" dirty="0">
                           <a:solidFill>
                             <a:srgbClr val="172A3A"/>
                           </a:solidFill>
@@ -3982,9 +3476,9 @@
                           <a:ea typeface="微软雅黑" pitchFamily="34" charset="-122"/>
                           <a:cs typeface="微软雅黑" pitchFamily="34" charset="-120"/>
                         </a:rPr>
-                        <a:t>150</a:t>
+                        <a:t>0.500</a:t>
                       </a:r>
-                      <a:endParaRPr lang="en-US" sz="1250" dirty="0">
+                      <a:endParaRPr lang="en-US" sz="1200" dirty="0">
                         <a:latin typeface="微软雅黑" charset="0"/>
                         <a:ea typeface="微软雅黑" charset="0"/>
                         <a:cs typeface="微软雅黑" charset="0"/>
@@ -4039,7 +3533,594 @@
                         <a:buNone/>
                       </a:pPr>
                       <a:r>
-                        <a:rPr lang="en-US" sz="1250" dirty="0">
+                        <a:rPr lang="en-US" sz="1200" dirty="0">
+                          <a:solidFill>
+                            <a:srgbClr val="172A3A"/>
+                          </a:solidFill>
+                          <a:latin typeface="微软雅黑" pitchFamily="34" charset="0"/>
+                          <a:ea typeface="微软雅黑" pitchFamily="34" charset="-122"/>
+                          <a:cs typeface="微软雅黑" pitchFamily="34" charset="-120"/>
+                        </a:rPr>
+                        <a:t>0.500</a:t>
+                      </a:r>
+                      <a:endParaRPr lang="en-US" sz="1200" dirty="0">
+                        <a:latin typeface="微软雅黑" charset="0"/>
+                        <a:ea typeface="微软雅黑" charset="0"/>
+                        <a:cs typeface="微软雅黑" charset="0"/>
+                      </a:endParaRPr>
+                    </a:p>
+                  </a:txBody>
+                  <a:tcPr marL="91440" marR="91440" marT="45720" marB="45720" anchor="ctr">
+                    <a:lnL w="9525" cap="flat" cmpd="sng" algn="ctr">
+                      <a:solidFill>
+                        <a:srgbClr val="D9E2EE"/>
+                      </a:solidFill>
+                      <a:prstDash val="solid"/>
+                      <a:round/>
+                      <a:headEnd type="none" w="med" len="med"/>
+                      <a:tailEnd type="none" w="med" len="med"/>
+                    </a:lnL>
+                    <a:lnR w="9525" cap="flat" cmpd="sng" algn="ctr">
+                      <a:solidFill>
+                        <a:srgbClr val="D9E2EE"/>
+                      </a:solidFill>
+                      <a:prstDash val="solid"/>
+                      <a:round/>
+                      <a:headEnd type="none" w="med" len="med"/>
+                      <a:tailEnd type="none" w="med" len="med"/>
+                    </a:lnR>
+                    <a:lnT w="9525" cap="flat" cmpd="sng" algn="ctr">
+                      <a:solidFill>
+                        <a:srgbClr val="D9E2EE"/>
+                      </a:solidFill>
+                      <a:prstDash val="solid"/>
+                      <a:round/>
+                      <a:headEnd type="none" w="med" len="med"/>
+                      <a:tailEnd type="none" w="med" len="med"/>
+                    </a:lnT>
+                    <a:lnB w="9525" cap="flat" cmpd="sng" algn="ctr">
+                      <a:solidFill>
+                        <a:srgbClr val="D9E2EE"/>
+                      </a:solidFill>
+                      <a:prstDash val="solid"/>
+                      <a:round/>
+                      <a:headEnd type="none" w="med" len="med"/>
+                      <a:tailEnd type="none" w="med" len="med"/>
+                    </a:lnB>
+                  </a:tcPr>
+                </a:tc>
+                <a:tc>
+                  <a:txBody>
+                    <a:bodyPr/>
+                    <a:lstStyle/>
+                    <a:p>
+                      <a:pPr algn="ctr" indent="0" marL="0">
+                        <a:buNone/>
+                      </a:pPr>
+                      <a:r>
+                        <a:rPr lang="en-US" sz="1200" dirty="0">
+                          <a:solidFill>
+                            <a:srgbClr val="172A3A"/>
+                          </a:solidFill>
+                          <a:latin typeface="微软雅黑" pitchFamily="34" charset="0"/>
+                          <a:ea typeface="微软雅黑" pitchFamily="34" charset="-122"/>
+                          <a:cs typeface="微软雅黑" pitchFamily="34" charset="-120"/>
+                        </a:rPr>
+                        <a:t>1.000</a:t>
+                      </a:r>
+                      <a:endParaRPr lang="en-US" sz="1200" dirty="0">
+                        <a:latin typeface="微软雅黑" charset="0"/>
+                        <a:ea typeface="微软雅黑" charset="0"/>
+                        <a:cs typeface="微软雅黑" charset="0"/>
+                      </a:endParaRPr>
+                    </a:p>
+                  </a:txBody>
+                  <a:tcPr marL="91440" marR="91440" marT="45720" marB="45720" anchor="ctr">
+                    <a:lnL w="9525" cap="flat" cmpd="sng" algn="ctr">
+                      <a:solidFill>
+                        <a:srgbClr val="D9E2EE"/>
+                      </a:solidFill>
+                      <a:prstDash val="solid"/>
+                      <a:round/>
+                      <a:headEnd type="none" w="med" len="med"/>
+                      <a:tailEnd type="none" w="med" len="med"/>
+                    </a:lnL>
+                    <a:lnR w="9525" cap="flat" cmpd="sng" algn="ctr">
+                      <a:solidFill>
+                        <a:srgbClr val="D9E2EE"/>
+                      </a:solidFill>
+                      <a:prstDash val="solid"/>
+                      <a:round/>
+                      <a:headEnd type="none" w="med" len="med"/>
+                      <a:tailEnd type="none" w="med" len="med"/>
+                    </a:lnR>
+                    <a:lnT w="9525" cap="flat" cmpd="sng" algn="ctr">
+                      <a:solidFill>
+                        <a:srgbClr val="D9E2EE"/>
+                      </a:solidFill>
+                      <a:prstDash val="solid"/>
+                      <a:round/>
+                      <a:headEnd type="none" w="med" len="med"/>
+                      <a:tailEnd type="none" w="med" len="med"/>
+                    </a:lnT>
+                    <a:lnB w="9525" cap="flat" cmpd="sng" algn="ctr">
+                      <a:solidFill>
+                        <a:srgbClr val="D9E2EE"/>
+                      </a:solidFill>
+                      <a:prstDash val="solid"/>
+                      <a:round/>
+                      <a:headEnd type="none" w="med" len="med"/>
+                      <a:tailEnd type="none" w="med" len="med"/>
+                    </a:lnB>
+                  </a:tcPr>
+                </a:tc>
+                <a:tc>
+                  <a:txBody>
+                    <a:bodyPr/>
+                    <a:lstStyle/>
+                    <a:p>
+                      <a:pPr algn="ctr" indent="0" marL="0">
+                        <a:buNone/>
+                      </a:pPr>
+                      <a:r>
+                        <a:rPr lang="en-US" sz="1200" dirty="0">
+                          <a:solidFill>
+                            <a:srgbClr val="172A3A"/>
+                          </a:solidFill>
+                          <a:latin typeface="微软雅黑" pitchFamily="34" charset="0"/>
+                          <a:ea typeface="微软雅黑" pitchFamily="34" charset="-122"/>
+                          <a:cs typeface="微软雅黑" pitchFamily="34" charset="-120"/>
+                        </a:rPr>
+                        <a:t>0</a:t>
+                      </a:r>
+                      <a:endParaRPr lang="en-US" sz="1200" dirty="0">
+                        <a:latin typeface="微软雅黑" charset="0"/>
+                        <a:ea typeface="微软雅黑" charset="0"/>
+                        <a:cs typeface="微软雅黑" charset="0"/>
+                      </a:endParaRPr>
+                    </a:p>
+                  </a:txBody>
+                  <a:tcPr marL="91440" marR="91440" marT="45720" marB="45720" anchor="ctr">
+                    <a:lnL w="9525" cap="flat" cmpd="sng" algn="ctr">
+                      <a:solidFill>
+                        <a:srgbClr val="D9E2EE"/>
+                      </a:solidFill>
+                      <a:prstDash val="solid"/>
+                      <a:round/>
+                      <a:headEnd type="none" w="med" len="med"/>
+                      <a:tailEnd type="none" w="med" len="med"/>
+                    </a:lnL>
+                    <a:lnR w="9525" cap="flat" cmpd="sng" algn="ctr">
+                      <a:solidFill>
+                        <a:srgbClr val="D9E2EE"/>
+                      </a:solidFill>
+                      <a:prstDash val="solid"/>
+                      <a:round/>
+                      <a:headEnd type="none" w="med" len="med"/>
+                      <a:tailEnd type="none" w="med" len="med"/>
+                    </a:lnR>
+                    <a:lnT w="9525" cap="flat" cmpd="sng" algn="ctr">
+                      <a:solidFill>
+                        <a:srgbClr val="D9E2EE"/>
+                      </a:solidFill>
+                      <a:prstDash val="solid"/>
+                      <a:round/>
+                      <a:headEnd type="none" w="med" len="med"/>
+                      <a:tailEnd type="none" w="med" len="med"/>
+                    </a:lnT>
+                    <a:lnB w="9525" cap="flat" cmpd="sng" algn="ctr">
+                      <a:solidFill>
+                        <a:srgbClr val="D9E2EE"/>
+                      </a:solidFill>
+                      <a:prstDash val="solid"/>
+                      <a:round/>
+                      <a:headEnd type="none" w="med" len="med"/>
+                      <a:tailEnd type="none" w="med" len="med"/>
+                    </a:lnB>
+                  </a:tcPr>
+                </a:tc>
+                <a:tc>
+                  <a:txBody>
+                    <a:bodyPr/>
+                    <a:lstStyle/>
+                    <a:p>
+                      <a:pPr algn="ctr" indent="0" marL="0">
+                        <a:buNone/>
+                      </a:pPr>
+                      <a:r>
+                        <a:rPr lang="en-US" sz="1200" dirty="0">
+                          <a:solidFill>
+                            <a:srgbClr val="172A3A"/>
+                          </a:solidFill>
+                          <a:latin typeface="微软雅黑" pitchFamily="34" charset="0"/>
+                          <a:ea typeface="微软雅黑" pitchFamily="34" charset="-122"/>
+                          <a:cs typeface="微软雅黑" pitchFamily="34" charset="-120"/>
+                        </a:rPr>
+                        <a:t>150</a:t>
+                      </a:r>
+                      <a:endParaRPr lang="en-US" sz="1200" dirty="0">
+                        <a:latin typeface="微软雅黑" charset="0"/>
+                        <a:ea typeface="微软雅黑" charset="0"/>
+                        <a:cs typeface="微软雅黑" charset="0"/>
+                      </a:endParaRPr>
+                    </a:p>
+                  </a:txBody>
+                  <a:tcPr marL="91440" marR="91440" marT="45720" marB="45720" anchor="ctr">
+                    <a:lnL w="9525" cap="flat" cmpd="sng" algn="ctr">
+                      <a:solidFill>
+                        <a:srgbClr val="D9E2EE"/>
+                      </a:solidFill>
+                      <a:prstDash val="solid"/>
+                      <a:round/>
+                      <a:headEnd type="none" w="med" len="med"/>
+                      <a:tailEnd type="none" w="med" len="med"/>
+                    </a:lnL>
+                    <a:lnR w="9525" cap="flat" cmpd="sng" algn="ctr">
+                      <a:solidFill>
+                        <a:srgbClr val="D9E2EE"/>
+                      </a:solidFill>
+                      <a:prstDash val="solid"/>
+                      <a:round/>
+                      <a:headEnd type="none" w="med" len="med"/>
+                      <a:tailEnd type="none" w="med" len="med"/>
+                    </a:lnR>
+                    <a:lnT w="9525" cap="flat" cmpd="sng" algn="ctr">
+                      <a:solidFill>
+                        <a:srgbClr val="D9E2EE"/>
+                      </a:solidFill>
+                      <a:prstDash val="solid"/>
+                      <a:round/>
+                      <a:headEnd type="none" w="med" len="med"/>
+                      <a:tailEnd type="none" w="med" len="med"/>
+                    </a:lnT>
+                    <a:lnB w="9525" cap="flat" cmpd="sng" algn="ctr">
+                      <a:solidFill>
+                        <a:srgbClr val="D9E2EE"/>
+                      </a:solidFill>
+                      <a:prstDash val="solid"/>
+                      <a:round/>
+                      <a:headEnd type="none" w="med" len="med"/>
+                      <a:tailEnd type="none" w="med" len="med"/>
+                    </a:lnB>
+                  </a:tcPr>
+                </a:tc>
+              </a:tr>
+              <a:tr h="457200">
+                <a:tc>
+                  <a:txBody>
+                    <a:bodyPr/>
+                    <a:lstStyle/>
+                    <a:p>
+                      <a:pPr algn="ctr" indent="0" marL="0">
+                        <a:buNone/>
+                      </a:pPr>
+                      <a:r>
+                        <a:rPr lang="en-US" sz="1200" dirty="0">
+                          <a:solidFill>
+                            <a:srgbClr val="172A3A"/>
+                          </a:solidFill>
+                          <a:latin typeface="微软雅黑" pitchFamily="34" charset="0"/>
+                          <a:ea typeface="微软雅黑" pitchFamily="34" charset="-122"/>
+                          <a:cs typeface="微软雅黑" pitchFamily="34" charset="-120"/>
+                        </a:rPr>
+                        <a:t>SmallCNN</a:t>
+                      </a:r>
+                      <a:endParaRPr lang="en-US" sz="1200" dirty="0">
+                        <a:latin typeface="微软雅黑" charset="0"/>
+                        <a:ea typeface="微软雅黑" charset="0"/>
+                        <a:cs typeface="微软雅黑" charset="0"/>
+                      </a:endParaRPr>
+                    </a:p>
+                  </a:txBody>
+                  <a:tcPr marL="91440" marR="91440" marT="45720" marB="45720" anchor="ctr">
+                    <a:lnL w="9525" cap="flat" cmpd="sng" algn="ctr">
+                      <a:solidFill>
+                        <a:srgbClr val="D9E2EE"/>
+                      </a:solidFill>
+                      <a:prstDash val="solid"/>
+                      <a:round/>
+                      <a:headEnd type="none" w="med" len="med"/>
+                      <a:tailEnd type="none" w="med" len="med"/>
+                    </a:lnL>
+                    <a:lnR w="9525" cap="flat" cmpd="sng" algn="ctr">
+                      <a:solidFill>
+                        <a:srgbClr val="D9E2EE"/>
+                      </a:solidFill>
+                      <a:prstDash val="solid"/>
+                      <a:round/>
+                      <a:headEnd type="none" w="med" len="med"/>
+                      <a:tailEnd type="none" w="med" len="med"/>
+                    </a:lnR>
+                    <a:lnT w="9525" cap="flat" cmpd="sng" algn="ctr">
+                      <a:solidFill>
+                        <a:srgbClr val="D9E2EE"/>
+                      </a:solidFill>
+                      <a:prstDash val="solid"/>
+                      <a:round/>
+                      <a:headEnd type="none" w="med" len="med"/>
+                      <a:tailEnd type="none" w="med" len="med"/>
+                    </a:lnT>
+                    <a:lnB w="9525" cap="flat" cmpd="sng" algn="ctr">
+                      <a:solidFill>
+                        <a:srgbClr val="D9E2EE"/>
+                      </a:solidFill>
+                      <a:prstDash val="solid"/>
+                      <a:round/>
+                      <a:headEnd type="none" w="med" len="med"/>
+                      <a:tailEnd type="none" w="med" len="med"/>
+                    </a:lnB>
+                  </a:tcPr>
+                </a:tc>
+                <a:tc>
+                  <a:txBody>
+                    <a:bodyPr/>
+                    <a:lstStyle/>
+                    <a:p>
+                      <a:pPr algn="ctr" indent="0" marL="0">
+                        <a:buNone/>
+                      </a:pPr>
+                      <a:r>
+                        <a:rPr lang="en-US" sz="1200" dirty="0">
+                          <a:solidFill>
+                            <a:srgbClr val="172A3A"/>
+                          </a:solidFill>
+                          <a:latin typeface="微软雅黑" pitchFamily="34" charset="0"/>
+                          <a:ea typeface="微软雅黑" pitchFamily="34" charset="-122"/>
+                          <a:cs typeface="微软雅黑" pitchFamily="34" charset="-120"/>
+                        </a:rPr>
+                        <a:t>0.813</a:t>
+                      </a:r>
+                      <a:endParaRPr lang="en-US" sz="1200" dirty="0">
+                        <a:latin typeface="微软雅黑" charset="0"/>
+                        <a:ea typeface="微软雅黑" charset="0"/>
+                        <a:cs typeface="微软雅黑" charset="0"/>
+                      </a:endParaRPr>
+                    </a:p>
+                  </a:txBody>
+                  <a:tcPr marL="91440" marR="91440" marT="45720" marB="45720" anchor="ctr">
+                    <a:lnL w="9525" cap="flat" cmpd="sng" algn="ctr">
+                      <a:solidFill>
+                        <a:srgbClr val="D9E2EE"/>
+                      </a:solidFill>
+                      <a:prstDash val="solid"/>
+                      <a:round/>
+                      <a:headEnd type="none" w="med" len="med"/>
+                      <a:tailEnd type="none" w="med" len="med"/>
+                    </a:lnL>
+                    <a:lnR w="9525" cap="flat" cmpd="sng" algn="ctr">
+                      <a:solidFill>
+                        <a:srgbClr val="D9E2EE"/>
+                      </a:solidFill>
+                      <a:prstDash val="solid"/>
+                      <a:round/>
+                      <a:headEnd type="none" w="med" len="med"/>
+                      <a:tailEnd type="none" w="med" len="med"/>
+                    </a:lnR>
+                    <a:lnT w="9525" cap="flat" cmpd="sng" algn="ctr">
+                      <a:solidFill>
+                        <a:srgbClr val="D9E2EE"/>
+                      </a:solidFill>
+                      <a:prstDash val="solid"/>
+                      <a:round/>
+                      <a:headEnd type="none" w="med" len="med"/>
+                      <a:tailEnd type="none" w="med" len="med"/>
+                    </a:lnT>
+                    <a:lnB w="9525" cap="flat" cmpd="sng" algn="ctr">
+                      <a:solidFill>
+                        <a:srgbClr val="D9E2EE"/>
+                      </a:solidFill>
+                      <a:prstDash val="solid"/>
+                      <a:round/>
+                      <a:headEnd type="none" w="med" len="med"/>
+                      <a:tailEnd type="none" w="med" len="med"/>
+                    </a:lnB>
+                  </a:tcPr>
+                </a:tc>
+                <a:tc>
+                  <a:txBody>
+                    <a:bodyPr/>
+                    <a:lstStyle/>
+                    <a:p>
+                      <a:pPr algn="ctr" indent="0" marL="0">
+                        <a:buNone/>
+                      </a:pPr>
+                      <a:r>
+                        <a:rPr lang="en-US" sz="1200" dirty="0">
+                          <a:solidFill>
+                            <a:srgbClr val="172A3A"/>
+                          </a:solidFill>
+                          <a:latin typeface="微软雅黑" pitchFamily="34" charset="0"/>
+                          <a:ea typeface="微软雅黑" pitchFamily="34" charset="-122"/>
+                          <a:cs typeface="微软雅黑" pitchFamily="34" charset="-120"/>
+                        </a:rPr>
+                        <a:t>0.892</a:t>
+                      </a:r>
+                      <a:endParaRPr lang="en-US" sz="1200" dirty="0">
+                        <a:latin typeface="微软雅黑" charset="0"/>
+                        <a:ea typeface="微软雅黑" charset="0"/>
+                        <a:cs typeface="微软雅黑" charset="0"/>
+                      </a:endParaRPr>
+                    </a:p>
+                  </a:txBody>
+                  <a:tcPr marL="91440" marR="91440" marT="45720" marB="45720" anchor="ctr">
+                    <a:lnL w="9525" cap="flat" cmpd="sng" algn="ctr">
+                      <a:solidFill>
+                        <a:srgbClr val="D9E2EE"/>
+                      </a:solidFill>
+                      <a:prstDash val="solid"/>
+                      <a:round/>
+                      <a:headEnd type="none" w="med" len="med"/>
+                      <a:tailEnd type="none" w="med" len="med"/>
+                    </a:lnL>
+                    <a:lnR w="9525" cap="flat" cmpd="sng" algn="ctr">
+                      <a:solidFill>
+                        <a:srgbClr val="D9E2EE"/>
+                      </a:solidFill>
+                      <a:prstDash val="solid"/>
+                      <a:round/>
+                      <a:headEnd type="none" w="med" len="med"/>
+                      <a:tailEnd type="none" w="med" len="med"/>
+                    </a:lnR>
+                    <a:lnT w="9525" cap="flat" cmpd="sng" algn="ctr">
+                      <a:solidFill>
+                        <a:srgbClr val="D9E2EE"/>
+                      </a:solidFill>
+                      <a:prstDash val="solid"/>
+                      <a:round/>
+                      <a:headEnd type="none" w="med" len="med"/>
+                      <a:tailEnd type="none" w="med" len="med"/>
+                    </a:lnT>
+                    <a:lnB w="9525" cap="flat" cmpd="sng" algn="ctr">
+                      <a:solidFill>
+                        <a:srgbClr val="D9E2EE"/>
+                      </a:solidFill>
+                      <a:prstDash val="solid"/>
+                      <a:round/>
+                      <a:headEnd type="none" w="med" len="med"/>
+                      <a:tailEnd type="none" w="med" len="med"/>
+                    </a:lnB>
+                  </a:tcPr>
+                </a:tc>
+                <a:tc>
+                  <a:txBody>
+                    <a:bodyPr/>
+                    <a:lstStyle/>
+                    <a:p>
+                      <a:pPr algn="ctr" indent="0" marL="0">
+                        <a:buNone/>
+                      </a:pPr>
+                      <a:r>
+                        <a:rPr lang="en-US" sz="1200" dirty="0">
+                          <a:solidFill>
+                            <a:srgbClr val="172A3A"/>
+                          </a:solidFill>
+                          <a:latin typeface="微软雅黑" pitchFamily="34" charset="0"/>
+                          <a:ea typeface="微软雅黑" pitchFamily="34" charset="-122"/>
+                          <a:cs typeface="微软雅黑" pitchFamily="34" charset="-120"/>
+                        </a:rPr>
+                        <a:t>0.713</a:t>
+                      </a:r>
+                      <a:endParaRPr lang="en-US" sz="1200" dirty="0">
+                        <a:latin typeface="微软雅黑" charset="0"/>
+                        <a:ea typeface="微软雅黑" charset="0"/>
+                        <a:cs typeface="微软雅黑" charset="0"/>
+                      </a:endParaRPr>
+                    </a:p>
+                  </a:txBody>
+                  <a:tcPr marL="91440" marR="91440" marT="45720" marB="45720" anchor="ctr">
+                    <a:lnL w="9525" cap="flat" cmpd="sng" algn="ctr">
+                      <a:solidFill>
+                        <a:srgbClr val="D9E2EE"/>
+                      </a:solidFill>
+                      <a:prstDash val="solid"/>
+                      <a:round/>
+                      <a:headEnd type="none" w="med" len="med"/>
+                      <a:tailEnd type="none" w="med" len="med"/>
+                    </a:lnL>
+                    <a:lnR w="9525" cap="flat" cmpd="sng" algn="ctr">
+                      <a:solidFill>
+                        <a:srgbClr val="D9E2EE"/>
+                      </a:solidFill>
+                      <a:prstDash val="solid"/>
+                      <a:round/>
+                      <a:headEnd type="none" w="med" len="med"/>
+                      <a:tailEnd type="none" w="med" len="med"/>
+                    </a:lnR>
+                    <a:lnT w="9525" cap="flat" cmpd="sng" algn="ctr">
+                      <a:solidFill>
+                        <a:srgbClr val="D9E2EE"/>
+                      </a:solidFill>
+                      <a:prstDash val="solid"/>
+                      <a:round/>
+                      <a:headEnd type="none" w="med" len="med"/>
+                      <a:tailEnd type="none" w="med" len="med"/>
+                    </a:lnT>
+                    <a:lnB w="9525" cap="flat" cmpd="sng" algn="ctr">
+                      <a:solidFill>
+                        <a:srgbClr val="D9E2EE"/>
+                      </a:solidFill>
+                      <a:prstDash val="solid"/>
+                      <a:round/>
+                      <a:headEnd type="none" w="med" len="med"/>
+                      <a:tailEnd type="none" w="med" len="med"/>
+                    </a:lnB>
+                  </a:tcPr>
+                </a:tc>
+                <a:tc>
+                  <a:txBody>
+                    <a:bodyPr/>
+                    <a:lstStyle/>
+                    <a:p>
+                      <a:pPr algn="ctr" indent="0" marL="0">
+                        <a:buNone/>
+                      </a:pPr>
+                      <a:r>
+                        <a:rPr lang="en-US" sz="1200" b="1" dirty="0">
+                          <a:solidFill>
+                            <a:srgbClr val="EC5F74"/>
+                          </a:solidFill>
+                          <a:latin typeface="微软雅黑" pitchFamily="34" charset="0"/>
+                          <a:ea typeface="微软雅黑" pitchFamily="34" charset="-122"/>
+                          <a:cs typeface="微软雅黑" pitchFamily="34" charset="-120"/>
+                        </a:rPr>
+                        <a:t>43</a:t>
+                      </a:r>
+                      <a:endParaRPr lang="en-US" sz="1200" dirty="0">
+                        <a:latin typeface="微软雅黑" charset="0"/>
+                        <a:ea typeface="微软雅黑" charset="0"/>
+                        <a:cs typeface="微软雅黑" charset="0"/>
+                      </a:endParaRPr>
+                    </a:p>
+                  </a:txBody>
+                  <a:tcPr marL="91440" marR="91440" marT="45720" marB="45720" anchor="ctr">
+                    <a:lnL w="9525" cap="flat" cmpd="sng" algn="ctr">
+                      <a:solidFill>
+                        <a:srgbClr val="D9E2EE"/>
+                      </a:solidFill>
+                      <a:prstDash val="solid"/>
+                      <a:round/>
+                      <a:headEnd type="none" w="med" len="med"/>
+                      <a:tailEnd type="none" w="med" len="med"/>
+                    </a:lnL>
+                    <a:lnR w="9525" cap="flat" cmpd="sng" algn="ctr">
+                      <a:solidFill>
+                        <a:srgbClr val="D9E2EE"/>
+                      </a:solidFill>
+                      <a:prstDash val="solid"/>
+                      <a:round/>
+                      <a:headEnd type="none" w="med" len="med"/>
+                      <a:tailEnd type="none" w="med" len="med"/>
+                    </a:lnR>
+                    <a:lnT w="9525" cap="flat" cmpd="sng" algn="ctr">
+                      <a:solidFill>
+                        <a:srgbClr val="D9E2EE"/>
+                      </a:solidFill>
+                      <a:prstDash val="solid"/>
+                      <a:round/>
+                      <a:headEnd type="none" w="med" len="med"/>
+                      <a:tailEnd type="none" w="med" len="med"/>
+                    </a:lnT>
+                    <a:lnB w="9525" cap="flat" cmpd="sng" algn="ctr">
+                      <a:solidFill>
+                        <a:srgbClr val="D9E2EE"/>
+                      </a:solidFill>
+                      <a:prstDash val="solid"/>
+                      <a:round/>
+                      <a:headEnd type="none" w="med" len="med"/>
+                      <a:tailEnd type="none" w="med" len="med"/>
+                    </a:lnB>
+                  </a:tcPr>
+                </a:tc>
+                <a:tc>
+                  <a:txBody>
+                    <a:bodyPr/>
+                    <a:lstStyle/>
+                    <a:p>
+                      <a:pPr algn="ctr" indent="0" marL="0">
+                        <a:buNone/>
+                      </a:pPr>
+                      <a:r>
+                        <a:rPr lang="en-US" sz="1200" dirty="0">
                           <a:solidFill>
                             <a:srgbClr val="172A3A"/>
                           </a:solidFill>
@@ -4049,7 +4130,7 @@
                         </a:rPr>
                         <a:t>13</a:t>
                       </a:r>
-                      <a:endParaRPr lang="en-US" sz="1250" dirty="0">
+                      <a:endParaRPr lang="en-US" sz="1200" dirty="0">
                         <a:latin typeface="微软雅黑" charset="0"/>
                         <a:ea typeface="微软雅黑" charset="0"/>
                         <a:cs typeface="微软雅黑" charset="0"/>
@@ -4096,6 +4177,1236 @@
                   </a:tcPr>
                 </a:tc>
               </a:tr>
+              <a:tr h="457200">
+                <a:tc>
+                  <a:txBody>
+                    <a:bodyPr/>
+                    <a:lstStyle/>
+                    <a:p>
+                      <a:pPr algn="ctr" indent="0" marL="0">
+                        <a:buNone/>
+                      </a:pPr>
+                      <a:r>
+                        <a:rPr lang="en-US" sz="1200" b="1" dirty="0">
+                          <a:solidFill>
+                            <a:srgbClr val="56CA95"/>
+                          </a:solidFill>
+                          <a:latin typeface="微软雅黑" pitchFamily="34" charset="0"/>
+                          <a:ea typeface="微软雅黑" pitchFamily="34" charset="-122"/>
+                          <a:cs typeface="微软雅黑" pitchFamily="34" charset="-120"/>
+                        </a:rPr>
+                        <a:t>ResNet18 pretrained @ 0.5（扩展）</a:t>
+                      </a:r>
+                      <a:endParaRPr lang="en-US" sz="1200" dirty="0">
+                        <a:latin typeface="微软雅黑" charset="0"/>
+                        <a:ea typeface="微软雅黑" charset="0"/>
+                        <a:cs typeface="微软雅黑" charset="0"/>
+                      </a:endParaRPr>
+                    </a:p>
+                  </a:txBody>
+                  <a:tcPr marL="91440" marR="91440" marT="45720" marB="45720" anchor="ctr">
+                    <a:lnL w="9525" cap="flat" cmpd="sng" algn="ctr">
+                      <a:solidFill>
+                        <a:srgbClr val="D9E2EE"/>
+                      </a:solidFill>
+                      <a:prstDash val="solid"/>
+                      <a:round/>
+                      <a:headEnd type="none" w="med" len="med"/>
+                      <a:tailEnd type="none" w="med" len="med"/>
+                    </a:lnL>
+                    <a:lnR w="9525" cap="flat" cmpd="sng" algn="ctr">
+                      <a:solidFill>
+                        <a:srgbClr val="D9E2EE"/>
+                      </a:solidFill>
+                      <a:prstDash val="solid"/>
+                      <a:round/>
+                      <a:headEnd type="none" w="med" len="med"/>
+                      <a:tailEnd type="none" w="med" len="med"/>
+                    </a:lnR>
+                    <a:lnT w="9525" cap="flat" cmpd="sng" algn="ctr">
+                      <a:solidFill>
+                        <a:srgbClr val="D9E2EE"/>
+                      </a:solidFill>
+                      <a:prstDash val="solid"/>
+                      <a:round/>
+                      <a:headEnd type="none" w="med" len="med"/>
+                      <a:tailEnd type="none" w="med" len="med"/>
+                    </a:lnT>
+                    <a:lnB w="9525" cap="flat" cmpd="sng" algn="ctr">
+                      <a:solidFill>
+                        <a:srgbClr val="D9E2EE"/>
+                      </a:solidFill>
+                      <a:prstDash val="solid"/>
+                      <a:round/>
+                      <a:headEnd type="none" w="med" len="med"/>
+                      <a:tailEnd type="none" w="med" len="med"/>
+                    </a:lnB>
+                    <a:solidFill>
+                      <a:srgbClr val="EAF2FD"/>
+                    </a:solidFill>
+                  </a:tcPr>
+                </a:tc>
+                <a:tc>
+                  <a:txBody>
+                    <a:bodyPr/>
+                    <a:lstStyle/>
+                    <a:p>
+                      <a:pPr algn="ctr" indent="0" marL="0">
+                        <a:buNone/>
+                      </a:pPr>
+                      <a:r>
+                        <a:rPr lang="en-US" sz="1200" b="1" dirty="0">
+                          <a:solidFill>
+                            <a:srgbClr val="56CA95"/>
+                          </a:solidFill>
+                          <a:latin typeface="微软雅黑" pitchFamily="34" charset="0"/>
+                          <a:ea typeface="微软雅黑" pitchFamily="34" charset="-122"/>
+                          <a:cs typeface="微软雅黑" pitchFamily="34" charset="-120"/>
+                        </a:rPr>
+                        <a:t>0.997</a:t>
+                      </a:r>
+                      <a:endParaRPr lang="en-US" sz="1200" dirty="0">
+                        <a:latin typeface="微软雅黑" charset="0"/>
+                        <a:ea typeface="微软雅黑" charset="0"/>
+                        <a:cs typeface="微软雅黑" charset="0"/>
+                      </a:endParaRPr>
+                    </a:p>
+                  </a:txBody>
+                  <a:tcPr marL="91440" marR="91440" marT="45720" marB="45720" anchor="ctr">
+                    <a:lnL w="9525" cap="flat" cmpd="sng" algn="ctr">
+                      <a:solidFill>
+                        <a:srgbClr val="D9E2EE"/>
+                      </a:solidFill>
+                      <a:prstDash val="solid"/>
+                      <a:round/>
+                      <a:headEnd type="none" w="med" len="med"/>
+                      <a:tailEnd type="none" w="med" len="med"/>
+                    </a:lnL>
+                    <a:lnR w="9525" cap="flat" cmpd="sng" algn="ctr">
+                      <a:solidFill>
+                        <a:srgbClr val="D9E2EE"/>
+                      </a:solidFill>
+                      <a:prstDash val="solid"/>
+                      <a:round/>
+                      <a:headEnd type="none" w="med" len="med"/>
+                      <a:tailEnd type="none" w="med" len="med"/>
+                    </a:lnR>
+                    <a:lnT w="9525" cap="flat" cmpd="sng" algn="ctr">
+                      <a:solidFill>
+                        <a:srgbClr val="D9E2EE"/>
+                      </a:solidFill>
+                      <a:prstDash val="solid"/>
+                      <a:round/>
+                      <a:headEnd type="none" w="med" len="med"/>
+                      <a:tailEnd type="none" w="med" len="med"/>
+                    </a:lnT>
+                    <a:lnB w="9525" cap="flat" cmpd="sng" algn="ctr">
+                      <a:solidFill>
+                        <a:srgbClr val="D9E2EE"/>
+                      </a:solidFill>
+                      <a:prstDash val="solid"/>
+                      <a:round/>
+                      <a:headEnd type="none" w="med" len="med"/>
+                      <a:tailEnd type="none" w="med" len="med"/>
+                    </a:lnB>
+                    <a:solidFill>
+                      <a:srgbClr val="EAF2FD"/>
+                    </a:solidFill>
+                  </a:tcPr>
+                </a:tc>
+                <a:tc>
+                  <a:txBody>
+                    <a:bodyPr/>
+                    <a:lstStyle/>
+                    <a:p>
+                      <a:pPr algn="ctr" indent="0" marL="0">
+                        <a:buNone/>
+                      </a:pPr>
+                      <a:r>
+                        <a:rPr lang="en-US" sz="1200" b="1" dirty="0">
+                          <a:solidFill>
+                            <a:srgbClr val="56CA95"/>
+                          </a:solidFill>
+                          <a:latin typeface="微软雅黑" pitchFamily="34" charset="0"/>
+                          <a:ea typeface="微软雅黑" pitchFamily="34" charset="-122"/>
+                          <a:cs typeface="微软雅黑" pitchFamily="34" charset="-120"/>
+                        </a:rPr>
+                        <a:t>0.993</a:t>
+                      </a:r>
+                      <a:endParaRPr lang="en-US" sz="1200" dirty="0">
+                        <a:latin typeface="微软雅黑" charset="0"/>
+                        <a:ea typeface="微软雅黑" charset="0"/>
+                        <a:cs typeface="微软雅黑" charset="0"/>
+                      </a:endParaRPr>
+                    </a:p>
+                  </a:txBody>
+                  <a:tcPr marL="91440" marR="91440" marT="45720" marB="45720" anchor="ctr">
+                    <a:lnL w="9525" cap="flat" cmpd="sng" algn="ctr">
+                      <a:solidFill>
+                        <a:srgbClr val="D9E2EE"/>
+                      </a:solidFill>
+                      <a:prstDash val="solid"/>
+                      <a:round/>
+                      <a:headEnd type="none" w="med" len="med"/>
+                      <a:tailEnd type="none" w="med" len="med"/>
+                    </a:lnL>
+                    <a:lnR w="9525" cap="flat" cmpd="sng" algn="ctr">
+                      <a:solidFill>
+                        <a:srgbClr val="D9E2EE"/>
+                      </a:solidFill>
+                      <a:prstDash val="solid"/>
+                      <a:round/>
+                      <a:headEnd type="none" w="med" len="med"/>
+                      <a:tailEnd type="none" w="med" len="med"/>
+                    </a:lnR>
+                    <a:lnT w="9525" cap="flat" cmpd="sng" algn="ctr">
+                      <a:solidFill>
+                        <a:srgbClr val="D9E2EE"/>
+                      </a:solidFill>
+                      <a:prstDash val="solid"/>
+                      <a:round/>
+                      <a:headEnd type="none" w="med" len="med"/>
+                      <a:tailEnd type="none" w="med" len="med"/>
+                    </a:lnT>
+                    <a:lnB w="9525" cap="flat" cmpd="sng" algn="ctr">
+                      <a:solidFill>
+                        <a:srgbClr val="D9E2EE"/>
+                      </a:solidFill>
+                      <a:prstDash val="solid"/>
+                      <a:round/>
+                      <a:headEnd type="none" w="med" len="med"/>
+                      <a:tailEnd type="none" w="med" len="med"/>
+                    </a:lnB>
+                    <a:solidFill>
+                      <a:srgbClr val="EAF2FD"/>
+                    </a:solidFill>
+                  </a:tcPr>
+                </a:tc>
+                <a:tc>
+                  <a:txBody>
+                    <a:bodyPr/>
+                    <a:lstStyle/>
+                    <a:p>
+                      <a:pPr algn="ctr" indent="0" marL="0">
+                        <a:buNone/>
+                      </a:pPr>
+                      <a:r>
+                        <a:rPr lang="en-US" sz="1200" b="1" dirty="0">
+                          <a:solidFill>
+                            <a:srgbClr val="56CA95"/>
+                          </a:solidFill>
+                          <a:latin typeface="微软雅黑" pitchFamily="34" charset="0"/>
+                          <a:ea typeface="微软雅黑" pitchFamily="34" charset="-122"/>
+                          <a:cs typeface="微软雅黑" pitchFamily="34" charset="-120"/>
+                        </a:rPr>
+                        <a:t>1.000</a:t>
+                      </a:r>
+                      <a:endParaRPr lang="en-US" sz="1200" dirty="0">
+                        <a:latin typeface="微软雅黑" charset="0"/>
+                        <a:ea typeface="微软雅黑" charset="0"/>
+                        <a:cs typeface="微软雅黑" charset="0"/>
+                      </a:endParaRPr>
+                    </a:p>
+                  </a:txBody>
+                  <a:tcPr marL="91440" marR="91440" marT="45720" marB="45720" anchor="ctr">
+                    <a:lnL w="9525" cap="flat" cmpd="sng" algn="ctr">
+                      <a:solidFill>
+                        <a:srgbClr val="D9E2EE"/>
+                      </a:solidFill>
+                      <a:prstDash val="solid"/>
+                      <a:round/>
+                      <a:headEnd type="none" w="med" len="med"/>
+                      <a:tailEnd type="none" w="med" len="med"/>
+                    </a:lnL>
+                    <a:lnR w="9525" cap="flat" cmpd="sng" algn="ctr">
+                      <a:solidFill>
+                        <a:srgbClr val="D9E2EE"/>
+                      </a:solidFill>
+                      <a:prstDash val="solid"/>
+                      <a:round/>
+                      <a:headEnd type="none" w="med" len="med"/>
+                      <a:tailEnd type="none" w="med" len="med"/>
+                    </a:lnR>
+                    <a:lnT w="9525" cap="flat" cmpd="sng" algn="ctr">
+                      <a:solidFill>
+                        <a:srgbClr val="D9E2EE"/>
+                      </a:solidFill>
+                      <a:prstDash val="solid"/>
+                      <a:round/>
+                      <a:headEnd type="none" w="med" len="med"/>
+                      <a:tailEnd type="none" w="med" len="med"/>
+                    </a:lnT>
+                    <a:lnB w="9525" cap="flat" cmpd="sng" algn="ctr">
+                      <a:solidFill>
+                        <a:srgbClr val="D9E2EE"/>
+                      </a:solidFill>
+                      <a:prstDash val="solid"/>
+                      <a:round/>
+                      <a:headEnd type="none" w="med" len="med"/>
+                      <a:tailEnd type="none" w="med" len="med"/>
+                    </a:lnB>
+                    <a:solidFill>
+                      <a:srgbClr val="EAF2FD"/>
+                    </a:solidFill>
+                  </a:tcPr>
+                </a:tc>
+                <a:tc>
+                  <a:txBody>
+                    <a:bodyPr/>
+                    <a:lstStyle/>
+                    <a:p>
+                      <a:pPr algn="ctr" indent="0" marL="0">
+                        <a:buNone/>
+                      </a:pPr>
+                      <a:r>
+                        <a:rPr lang="en-US" sz="1200" b="1" dirty="0">
+                          <a:solidFill>
+                            <a:srgbClr val="56CA95"/>
+                          </a:solidFill>
+                          <a:latin typeface="微软雅黑" pitchFamily="34" charset="0"/>
+                          <a:ea typeface="微软雅黑" pitchFamily="34" charset="-122"/>
+                          <a:cs typeface="微软雅黑" pitchFamily="34" charset="-120"/>
+                        </a:rPr>
+                        <a:t>0</a:t>
+                      </a:r>
+                      <a:endParaRPr lang="en-US" sz="1200" dirty="0">
+                        <a:latin typeface="微软雅黑" charset="0"/>
+                        <a:ea typeface="微软雅黑" charset="0"/>
+                        <a:cs typeface="微软雅黑" charset="0"/>
+                      </a:endParaRPr>
+                    </a:p>
+                  </a:txBody>
+                  <a:tcPr marL="91440" marR="91440" marT="45720" marB="45720" anchor="ctr">
+                    <a:lnL w="9525" cap="flat" cmpd="sng" algn="ctr">
+                      <a:solidFill>
+                        <a:srgbClr val="D9E2EE"/>
+                      </a:solidFill>
+                      <a:prstDash val="solid"/>
+                      <a:round/>
+                      <a:headEnd type="none" w="med" len="med"/>
+                      <a:tailEnd type="none" w="med" len="med"/>
+                    </a:lnL>
+                    <a:lnR w="9525" cap="flat" cmpd="sng" algn="ctr">
+                      <a:solidFill>
+                        <a:srgbClr val="D9E2EE"/>
+                      </a:solidFill>
+                      <a:prstDash val="solid"/>
+                      <a:round/>
+                      <a:headEnd type="none" w="med" len="med"/>
+                      <a:tailEnd type="none" w="med" len="med"/>
+                    </a:lnR>
+                    <a:lnT w="9525" cap="flat" cmpd="sng" algn="ctr">
+                      <a:solidFill>
+                        <a:srgbClr val="D9E2EE"/>
+                      </a:solidFill>
+                      <a:prstDash val="solid"/>
+                      <a:round/>
+                      <a:headEnd type="none" w="med" len="med"/>
+                      <a:tailEnd type="none" w="med" len="med"/>
+                    </a:lnT>
+                    <a:lnB w="9525" cap="flat" cmpd="sng" algn="ctr">
+                      <a:solidFill>
+                        <a:srgbClr val="D9E2EE"/>
+                      </a:solidFill>
+                      <a:prstDash val="solid"/>
+                      <a:round/>
+                      <a:headEnd type="none" w="med" len="med"/>
+                      <a:tailEnd type="none" w="med" len="med"/>
+                    </a:lnB>
+                    <a:solidFill>
+                      <a:srgbClr val="EAF2FD"/>
+                    </a:solidFill>
+                  </a:tcPr>
+                </a:tc>
+                <a:tc>
+                  <a:txBody>
+                    <a:bodyPr/>
+                    <a:lstStyle/>
+                    <a:p>
+                      <a:pPr algn="ctr" indent="0" marL="0">
+                        <a:buNone/>
+                      </a:pPr>
+                      <a:r>
+                        <a:rPr lang="en-US" sz="1200" b="1" dirty="0">
+                          <a:solidFill>
+                            <a:srgbClr val="56CA95"/>
+                          </a:solidFill>
+                          <a:latin typeface="微软雅黑" pitchFamily="34" charset="0"/>
+                          <a:ea typeface="微软雅黑" pitchFamily="34" charset="-122"/>
+                          <a:cs typeface="微软雅黑" pitchFamily="34" charset="-120"/>
+                        </a:rPr>
+                        <a:t>1</a:t>
+                      </a:r>
+                      <a:endParaRPr lang="en-US" sz="1200" dirty="0">
+                        <a:latin typeface="微软雅黑" charset="0"/>
+                        <a:ea typeface="微软雅黑" charset="0"/>
+                        <a:cs typeface="微软雅黑" charset="0"/>
+                      </a:endParaRPr>
+                    </a:p>
+                  </a:txBody>
+                  <a:tcPr marL="91440" marR="91440" marT="45720" marB="45720" anchor="ctr">
+                    <a:lnL w="9525" cap="flat" cmpd="sng" algn="ctr">
+                      <a:solidFill>
+                        <a:srgbClr val="D9E2EE"/>
+                      </a:solidFill>
+                      <a:prstDash val="solid"/>
+                      <a:round/>
+                      <a:headEnd type="none" w="med" len="med"/>
+                      <a:tailEnd type="none" w="med" len="med"/>
+                    </a:lnL>
+                    <a:lnR w="9525" cap="flat" cmpd="sng" algn="ctr">
+                      <a:solidFill>
+                        <a:srgbClr val="D9E2EE"/>
+                      </a:solidFill>
+                      <a:prstDash val="solid"/>
+                      <a:round/>
+                      <a:headEnd type="none" w="med" len="med"/>
+                      <a:tailEnd type="none" w="med" len="med"/>
+                    </a:lnR>
+                    <a:lnT w="9525" cap="flat" cmpd="sng" algn="ctr">
+                      <a:solidFill>
+                        <a:srgbClr val="D9E2EE"/>
+                      </a:solidFill>
+                      <a:prstDash val="solid"/>
+                      <a:round/>
+                      <a:headEnd type="none" w="med" len="med"/>
+                      <a:tailEnd type="none" w="med" len="med"/>
+                    </a:lnT>
+                    <a:lnB w="9525" cap="flat" cmpd="sng" algn="ctr">
+                      <a:solidFill>
+                        <a:srgbClr val="D9E2EE"/>
+                      </a:solidFill>
+                      <a:prstDash val="solid"/>
+                      <a:round/>
+                      <a:headEnd type="none" w="med" len="med"/>
+                      <a:tailEnd type="none" w="med" len="med"/>
+                    </a:lnB>
+                    <a:solidFill>
+                      <a:srgbClr val="EAF2FD"/>
+                    </a:solidFill>
+                  </a:tcPr>
+                </a:tc>
+              </a:tr>
+              <a:tr h="457200">
+                <a:tc>
+                  <a:txBody>
+                    <a:bodyPr/>
+                    <a:lstStyle/>
+                    <a:p>
+                      <a:pPr algn="ctr" indent="0" marL="0">
+                        <a:buNone/>
+                      </a:pPr>
+                      <a:r>
+                        <a:rPr lang="en-US" sz="1200" dirty="0">
+                          <a:solidFill>
+                            <a:srgbClr val="172A3A"/>
+                          </a:solidFill>
+                          <a:latin typeface="微软雅黑" pitchFamily="34" charset="0"/>
+                          <a:ea typeface="微软雅黑" pitchFamily="34" charset="-122"/>
+                          <a:cs typeface="微软雅黑" pitchFamily="34" charset="-120"/>
+                        </a:rPr>
+                        <a:t>ResNet18 pretrained @ 0.9996（扩展）</a:t>
+                      </a:r>
+                      <a:endParaRPr lang="en-US" sz="1200" dirty="0">
+                        <a:latin typeface="微软雅黑" charset="0"/>
+                        <a:ea typeface="微软雅黑" charset="0"/>
+                        <a:cs typeface="微软雅黑" charset="0"/>
+                      </a:endParaRPr>
+                    </a:p>
+                  </a:txBody>
+                  <a:tcPr marL="91440" marR="91440" marT="45720" marB="45720" anchor="ctr">
+                    <a:lnL w="9525" cap="flat" cmpd="sng" algn="ctr">
+                      <a:solidFill>
+                        <a:srgbClr val="D9E2EE"/>
+                      </a:solidFill>
+                      <a:prstDash val="solid"/>
+                      <a:round/>
+                      <a:headEnd type="none" w="med" len="med"/>
+                      <a:tailEnd type="none" w="med" len="med"/>
+                    </a:lnL>
+                    <a:lnR w="9525" cap="flat" cmpd="sng" algn="ctr">
+                      <a:solidFill>
+                        <a:srgbClr val="D9E2EE"/>
+                      </a:solidFill>
+                      <a:prstDash val="solid"/>
+                      <a:round/>
+                      <a:headEnd type="none" w="med" len="med"/>
+                      <a:tailEnd type="none" w="med" len="med"/>
+                    </a:lnR>
+                    <a:lnT w="9525" cap="flat" cmpd="sng" algn="ctr">
+                      <a:solidFill>
+                        <a:srgbClr val="D9E2EE"/>
+                      </a:solidFill>
+                      <a:prstDash val="solid"/>
+                      <a:round/>
+                      <a:headEnd type="none" w="med" len="med"/>
+                      <a:tailEnd type="none" w="med" len="med"/>
+                    </a:lnT>
+                    <a:lnB w="9525" cap="flat" cmpd="sng" algn="ctr">
+                      <a:solidFill>
+                        <a:srgbClr val="D9E2EE"/>
+                      </a:solidFill>
+                      <a:prstDash val="solid"/>
+                      <a:round/>
+                      <a:headEnd type="none" w="med" len="med"/>
+                      <a:tailEnd type="none" w="med" len="med"/>
+                    </a:lnB>
+                    <a:solidFill>
+                      <a:srgbClr val="EAF2FD"/>
+                    </a:solidFill>
+                  </a:tcPr>
+                </a:tc>
+                <a:tc>
+                  <a:txBody>
+                    <a:bodyPr/>
+                    <a:lstStyle/>
+                    <a:p>
+                      <a:pPr algn="ctr" indent="0" marL="0">
+                        <a:buNone/>
+                      </a:pPr>
+                      <a:r>
+                        <a:rPr lang="en-US" sz="1200" dirty="0">
+                          <a:solidFill>
+                            <a:srgbClr val="172A3A"/>
+                          </a:solidFill>
+                          <a:latin typeface="微软雅黑" pitchFamily="34" charset="0"/>
+                          <a:ea typeface="微软雅黑" pitchFamily="34" charset="-122"/>
+                          <a:cs typeface="微软雅黑" pitchFamily="34" charset="-120"/>
+                        </a:rPr>
+                        <a:t>0.953</a:t>
+                      </a:r>
+                      <a:endParaRPr lang="en-US" sz="1200" dirty="0">
+                        <a:latin typeface="微软雅黑" charset="0"/>
+                        <a:ea typeface="微软雅黑" charset="0"/>
+                        <a:cs typeface="微软雅黑" charset="0"/>
+                      </a:endParaRPr>
+                    </a:p>
+                  </a:txBody>
+                  <a:tcPr marL="91440" marR="91440" marT="45720" marB="45720" anchor="ctr">
+                    <a:lnL w="9525" cap="flat" cmpd="sng" algn="ctr">
+                      <a:solidFill>
+                        <a:srgbClr val="D9E2EE"/>
+                      </a:solidFill>
+                      <a:prstDash val="solid"/>
+                      <a:round/>
+                      <a:headEnd type="none" w="med" len="med"/>
+                      <a:tailEnd type="none" w="med" len="med"/>
+                    </a:lnL>
+                    <a:lnR w="9525" cap="flat" cmpd="sng" algn="ctr">
+                      <a:solidFill>
+                        <a:srgbClr val="D9E2EE"/>
+                      </a:solidFill>
+                      <a:prstDash val="solid"/>
+                      <a:round/>
+                      <a:headEnd type="none" w="med" len="med"/>
+                      <a:tailEnd type="none" w="med" len="med"/>
+                    </a:lnR>
+                    <a:lnT w="9525" cap="flat" cmpd="sng" algn="ctr">
+                      <a:solidFill>
+                        <a:srgbClr val="D9E2EE"/>
+                      </a:solidFill>
+                      <a:prstDash val="solid"/>
+                      <a:round/>
+                      <a:headEnd type="none" w="med" len="med"/>
+                      <a:tailEnd type="none" w="med" len="med"/>
+                    </a:lnT>
+                    <a:lnB w="9525" cap="flat" cmpd="sng" algn="ctr">
+                      <a:solidFill>
+                        <a:srgbClr val="D9E2EE"/>
+                      </a:solidFill>
+                      <a:prstDash val="solid"/>
+                      <a:round/>
+                      <a:headEnd type="none" w="med" len="med"/>
+                      <a:tailEnd type="none" w="med" len="med"/>
+                    </a:lnB>
+                    <a:solidFill>
+                      <a:srgbClr val="EAF2FD"/>
+                    </a:solidFill>
+                  </a:tcPr>
+                </a:tc>
+                <a:tc>
+                  <a:txBody>
+                    <a:bodyPr/>
+                    <a:lstStyle/>
+                    <a:p>
+                      <a:pPr algn="ctr" indent="0" marL="0">
+                        <a:buNone/>
+                      </a:pPr>
+                      <a:r>
+                        <a:rPr lang="en-US" sz="1200" dirty="0">
+                          <a:solidFill>
+                            <a:srgbClr val="172A3A"/>
+                          </a:solidFill>
+                          <a:latin typeface="微软雅黑" pitchFamily="34" charset="0"/>
+                          <a:ea typeface="微软雅黑" pitchFamily="34" charset="-122"/>
+                          <a:cs typeface="微软雅黑" pitchFamily="34" charset="-120"/>
+                        </a:rPr>
+                        <a:t>1.000</a:t>
+                      </a:r>
+                      <a:endParaRPr lang="en-US" sz="1200" dirty="0">
+                        <a:latin typeface="微软雅黑" charset="0"/>
+                        <a:ea typeface="微软雅黑" charset="0"/>
+                        <a:cs typeface="微软雅黑" charset="0"/>
+                      </a:endParaRPr>
+                    </a:p>
+                  </a:txBody>
+                  <a:tcPr marL="91440" marR="91440" marT="45720" marB="45720" anchor="ctr">
+                    <a:lnL w="9525" cap="flat" cmpd="sng" algn="ctr">
+                      <a:solidFill>
+                        <a:srgbClr val="D9E2EE"/>
+                      </a:solidFill>
+                      <a:prstDash val="solid"/>
+                      <a:round/>
+                      <a:headEnd type="none" w="med" len="med"/>
+                      <a:tailEnd type="none" w="med" len="med"/>
+                    </a:lnL>
+                    <a:lnR w="9525" cap="flat" cmpd="sng" algn="ctr">
+                      <a:solidFill>
+                        <a:srgbClr val="D9E2EE"/>
+                      </a:solidFill>
+                      <a:prstDash val="solid"/>
+                      <a:round/>
+                      <a:headEnd type="none" w="med" len="med"/>
+                      <a:tailEnd type="none" w="med" len="med"/>
+                    </a:lnR>
+                    <a:lnT w="9525" cap="flat" cmpd="sng" algn="ctr">
+                      <a:solidFill>
+                        <a:srgbClr val="D9E2EE"/>
+                      </a:solidFill>
+                      <a:prstDash val="solid"/>
+                      <a:round/>
+                      <a:headEnd type="none" w="med" len="med"/>
+                      <a:tailEnd type="none" w="med" len="med"/>
+                    </a:lnT>
+                    <a:lnB w="9525" cap="flat" cmpd="sng" algn="ctr">
+                      <a:solidFill>
+                        <a:srgbClr val="D9E2EE"/>
+                      </a:solidFill>
+                      <a:prstDash val="solid"/>
+                      <a:round/>
+                      <a:headEnd type="none" w="med" len="med"/>
+                      <a:tailEnd type="none" w="med" len="med"/>
+                    </a:lnB>
+                    <a:solidFill>
+                      <a:srgbClr val="EAF2FD"/>
+                    </a:solidFill>
+                  </a:tcPr>
+                </a:tc>
+                <a:tc>
+                  <a:txBody>
+                    <a:bodyPr/>
+                    <a:lstStyle/>
+                    <a:p>
+                      <a:pPr algn="ctr" indent="0" marL="0">
+                        <a:buNone/>
+                      </a:pPr>
+                      <a:r>
+                        <a:rPr lang="en-US" sz="1200" dirty="0">
+                          <a:solidFill>
+                            <a:srgbClr val="172A3A"/>
+                          </a:solidFill>
+                          <a:latin typeface="微软雅黑" pitchFamily="34" charset="0"/>
+                          <a:ea typeface="微软雅黑" pitchFamily="34" charset="-122"/>
+                          <a:cs typeface="微软雅黑" pitchFamily="34" charset="-120"/>
+                        </a:rPr>
+                        <a:t>0.907</a:t>
+                      </a:r>
+                      <a:endParaRPr lang="en-US" sz="1200" dirty="0">
+                        <a:latin typeface="微软雅黑" charset="0"/>
+                        <a:ea typeface="微软雅黑" charset="0"/>
+                        <a:cs typeface="微软雅黑" charset="0"/>
+                      </a:endParaRPr>
+                    </a:p>
+                  </a:txBody>
+                  <a:tcPr marL="91440" marR="91440" marT="45720" marB="45720" anchor="ctr">
+                    <a:lnL w="9525" cap="flat" cmpd="sng" algn="ctr">
+                      <a:solidFill>
+                        <a:srgbClr val="D9E2EE"/>
+                      </a:solidFill>
+                      <a:prstDash val="solid"/>
+                      <a:round/>
+                      <a:headEnd type="none" w="med" len="med"/>
+                      <a:tailEnd type="none" w="med" len="med"/>
+                    </a:lnL>
+                    <a:lnR w="9525" cap="flat" cmpd="sng" algn="ctr">
+                      <a:solidFill>
+                        <a:srgbClr val="D9E2EE"/>
+                      </a:solidFill>
+                      <a:prstDash val="solid"/>
+                      <a:round/>
+                      <a:headEnd type="none" w="med" len="med"/>
+                      <a:tailEnd type="none" w="med" len="med"/>
+                    </a:lnR>
+                    <a:lnT w="9525" cap="flat" cmpd="sng" algn="ctr">
+                      <a:solidFill>
+                        <a:srgbClr val="D9E2EE"/>
+                      </a:solidFill>
+                      <a:prstDash val="solid"/>
+                      <a:round/>
+                      <a:headEnd type="none" w="med" len="med"/>
+                      <a:tailEnd type="none" w="med" len="med"/>
+                    </a:lnT>
+                    <a:lnB w="9525" cap="flat" cmpd="sng" algn="ctr">
+                      <a:solidFill>
+                        <a:srgbClr val="D9E2EE"/>
+                      </a:solidFill>
+                      <a:prstDash val="solid"/>
+                      <a:round/>
+                      <a:headEnd type="none" w="med" len="med"/>
+                      <a:tailEnd type="none" w="med" len="med"/>
+                    </a:lnB>
+                    <a:solidFill>
+                      <a:srgbClr val="EAF2FD"/>
+                    </a:solidFill>
+                  </a:tcPr>
+                </a:tc>
+                <a:tc>
+                  <a:txBody>
+                    <a:bodyPr/>
+                    <a:lstStyle/>
+                    <a:p>
+                      <a:pPr algn="ctr" indent="0" marL="0">
+                        <a:buNone/>
+                      </a:pPr>
+                      <a:r>
+                        <a:rPr lang="en-US" sz="1200" dirty="0">
+                          <a:solidFill>
+                            <a:srgbClr val="EC5F74"/>
+                          </a:solidFill>
+                          <a:latin typeface="微软雅黑" pitchFamily="34" charset="0"/>
+                          <a:ea typeface="微软雅黑" pitchFamily="34" charset="-122"/>
+                          <a:cs typeface="微软雅黑" pitchFamily="34" charset="-120"/>
+                        </a:rPr>
+                        <a:t>14</a:t>
+                      </a:r>
+                      <a:endParaRPr lang="en-US" sz="1200" dirty="0">
+                        <a:latin typeface="微软雅黑" charset="0"/>
+                        <a:ea typeface="微软雅黑" charset="0"/>
+                        <a:cs typeface="微软雅黑" charset="0"/>
+                      </a:endParaRPr>
+                    </a:p>
+                  </a:txBody>
+                  <a:tcPr marL="91440" marR="91440" marT="45720" marB="45720" anchor="ctr">
+                    <a:lnL w="9525" cap="flat" cmpd="sng" algn="ctr">
+                      <a:solidFill>
+                        <a:srgbClr val="D9E2EE"/>
+                      </a:solidFill>
+                      <a:prstDash val="solid"/>
+                      <a:round/>
+                      <a:headEnd type="none" w="med" len="med"/>
+                      <a:tailEnd type="none" w="med" len="med"/>
+                    </a:lnL>
+                    <a:lnR w="9525" cap="flat" cmpd="sng" algn="ctr">
+                      <a:solidFill>
+                        <a:srgbClr val="D9E2EE"/>
+                      </a:solidFill>
+                      <a:prstDash val="solid"/>
+                      <a:round/>
+                      <a:headEnd type="none" w="med" len="med"/>
+                      <a:tailEnd type="none" w="med" len="med"/>
+                    </a:lnR>
+                    <a:lnT w="9525" cap="flat" cmpd="sng" algn="ctr">
+                      <a:solidFill>
+                        <a:srgbClr val="D9E2EE"/>
+                      </a:solidFill>
+                      <a:prstDash val="solid"/>
+                      <a:round/>
+                      <a:headEnd type="none" w="med" len="med"/>
+                      <a:tailEnd type="none" w="med" len="med"/>
+                    </a:lnT>
+                    <a:lnB w="9525" cap="flat" cmpd="sng" algn="ctr">
+                      <a:solidFill>
+                        <a:srgbClr val="D9E2EE"/>
+                      </a:solidFill>
+                      <a:prstDash val="solid"/>
+                      <a:round/>
+                      <a:headEnd type="none" w="med" len="med"/>
+                      <a:tailEnd type="none" w="med" len="med"/>
+                    </a:lnB>
+                    <a:solidFill>
+                      <a:srgbClr val="EAF2FD"/>
+                    </a:solidFill>
+                  </a:tcPr>
+                </a:tc>
+                <a:tc>
+                  <a:txBody>
+                    <a:bodyPr/>
+                    <a:lstStyle/>
+                    <a:p>
+                      <a:pPr algn="ctr" indent="0" marL="0">
+                        <a:buNone/>
+                      </a:pPr>
+                      <a:r>
+                        <a:rPr lang="en-US" sz="1200" dirty="0">
+                          <a:solidFill>
+                            <a:srgbClr val="172A3A"/>
+                          </a:solidFill>
+                          <a:latin typeface="微软雅黑" pitchFamily="34" charset="0"/>
+                          <a:ea typeface="微软雅黑" pitchFamily="34" charset="-122"/>
+                          <a:cs typeface="微软雅黑" pitchFamily="34" charset="-120"/>
+                        </a:rPr>
+                        <a:t>0</a:t>
+                      </a:r>
+                      <a:endParaRPr lang="en-US" sz="1200" dirty="0">
+                        <a:latin typeface="微软雅黑" charset="0"/>
+                        <a:ea typeface="微软雅黑" charset="0"/>
+                        <a:cs typeface="微软雅黑" charset="0"/>
+                      </a:endParaRPr>
+                    </a:p>
+                  </a:txBody>
+                  <a:tcPr marL="91440" marR="91440" marT="45720" marB="45720" anchor="ctr">
+                    <a:lnL w="9525" cap="flat" cmpd="sng" algn="ctr">
+                      <a:solidFill>
+                        <a:srgbClr val="D9E2EE"/>
+                      </a:solidFill>
+                      <a:prstDash val="solid"/>
+                      <a:round/>
+                      <a:headEnd type="none" w="med" len="med"/>
+                      <a:tailEnd type="none" w="med" len="med"/>
+                    </a:lnL>
+                    <a:lnR w="9525" cap="flat" cmpd="sng" algn="ctr">
+                      <a:solidFill>
+                        <a:srgbClr val="D9E2EE"/>
+                      </a:solidFill>
+                      <a:prstDash val="solid"/>
+                      <a:round/>
+                      <a:headEnd type="none" w="med" len="med"/>
+                      <a:tailEnd type="none" w="med" len="med"/>
+                    </a:lnR>
+                    <a:lnT w="9525" cap="flat" cmpd="sng" algn="ctr">
+                      <a:solidFill>
+                        <a:srgbClr val="D9E2EE"/>
+                      </a:solidFill>
+                      <a:prstDash val="solid"/>
+                      <a:round/>
+                      <a:headEnd type="none" w="med" len="med"/>
+                      <a:tailEnd type="none" w="med" len="med"/>
+                    </a:lnT>
+                    <a:lnB w="9525" cap="flat" cmpd="sng" algn="ctr">
+                      <a:solidFill>
+                        <a:srgbClr val="D9E2EE"/>
+                      </a:solidFill>
+                      <a:prstDash val="solid"/>
+                      <a:round/>
+                      <a:headEnd type="none" w="med" len="med"/>
+                      <a:tailEnd type="none" w="med" len="med"/>
+                    </a:lnB>
+                    <a:solidFill>
+                      <a:srgbClr val="EAF2FD"/>
+                    </a:solidFill>
+                  </a:tcPr>
+                </a:tc>
+              </a:tr>
+              <a:tr h="457200">
+                <a:tc>
+                  <a:txBody>
+                    <a:bodyPr/>
+                    <a:lstStyle/>
+                    <a:p>
+                      <a:pPr algn="ctr" indent="0" marL="0">
+                        <a:buNone/>
+                      </a:pPr>
+                      <a:r>
+                        <a:rPr lang="en-US" sz="1200" dirty="0">
+                          <a:solidFill>
+                            <a:srgbClr val="172A3A"/>
+                          </a:solidFill>
+                          <a:latin typeface="微软雅黑" pitchFamily="34" charset="0"/>
+                          <a:ea typeface="微软雅黑" pitchFamily="34" charset="-122"/>
+                          <a:cs typeface="微软雅黑" pitchFamily="34" charset="-120"/>
+                        </a:rPr>
+                        <a:t>ResNet18 scratch @ 0.5（扩展）</a:t>
+                      </a:r>
+                      <a:endParaRPr lang="en-US" sz="1200" dirty="0">
+                        <a:latin typeface="微软雅黑" charset="0"/>
+                        <a:ea typeface="微软雅黑" charset="0"/>
+                        <a:cs typeface="微软雅黑" charset="0"/>
+                      </a:endParaRPr>
+                    </a:p>
+                  </a:txBody>
+                  <a:tcPr marL="91440" marR="91440" marT="45720" marB="45720" anchor="ctr">
+                    <a:lnL w="9525" cap="flat" cmpd="sng" algn="ctr">
+                      <a:solidFill>
+                        <a:srgbClr val="D9E2EE"/>
+                      </a:solidFill>
+                      <a:prstDash val="solid"/>
+                      <a:round/>
+                      <a:headEnd type="none" w="med" len="med"/>
+                      <a:tailEnd type="none" w="med" len="med"/>
+                    </a:lnL>
+                    <a:lnR w="9525" cap="flat" cmpd="sng" algn="ctr">
+                      <a:solidFill>
+                        <a:srgbClr val="D9E2EE"/>
+                      </a:solidFill>
+                      <a:prstDash val="solid"/>
+                      <a:round/>
+                      <a:headEnd type="none" w="med" len="med"/>
+                      <a:tailEnd type="none" w="med" len="med"/>
+                    </a:lnR>
+                    <a:lnT w="9525" cap="flat" cmpd="sng" algn="ctr">
+                      <a:solidFill>
+                        <a:srgbClr val="D9E2EE"/>
+                      </a:solidFill>
+                      <a:prstDash val="solid"/>
+                      <a:round/>
+                      <a:headEnd type="none" w="med" len="med"/>
+                      <a:tailEnd type="none" w="med" len="med"/>
+                    </a:lnT>
+                    <a:lnB w="9525" cap="flat" cmpd="sng" algn="ctr">
+                      <a:solidFill>
+                        <a:srgbClr val="D9E2EE"/>
+                      </a:solidFill>
+                      <a:prstDash val="solid"/>
+                      <a:round/>
+                      <a:headEnd type="none" w="med" len="med"/>
+                      <a:tailEnd type="none" w="med" len="med"/>
+                    </a:lnB>
+                    <a:solidFill>
+                      <a:srgbClr val="EAF2FD"/>
+                    </a:solidFill>
+                  </a:tcPr>
+                </a:tc>
+                <a:tc>
+                  <a:txBody>
+                    <a:bodyPr/>
+                    <a:lstStyle/>
+                    <a:p>
+                      <a:pPr algn="ctr" indent="0" marL="0">
+                        <a:buNone/>
+                      </a:pPr>
+                      <a:r>
+                        <a:rPr lang="en-US" sz="1200" dirty="0">
+                          <a:solidFill>
+                            <a:srgbClr val="172A3A"/>
+                          </a:solidFill>
+                          <a:latin typeface="微软雅黑" pitchFamily="34" charset="0"/>
+                          <a:ea typeface="微软雅黑" pitchFamily="34" charset="-122"/>
+                          <a:cs typeface="微软雅黑" pitchFamily="34" charset="-120"/>
+                        </a:rPr>
+                        <a:t>0.983</a:t>
+                      </a:r>
+                      <a:endParaRPr lang="en-US" sz="1200" dirty="0">
+                        <a:latin typeface="微软雅黑" charset="0"/>
+                        <a:ea typeface="微软雅黑" charset="0"/>
+                        <a:cs typeface="微软雅黑" charset="0"/>
+                      </a:endParaRPr>
+                    </a:p>
+                  </a:txBody>
+                  <a:tcPr marL="91440" marR="91440" marT="45720" marB="45720" anchor="ctr">
+                    <a:lnL w="9525" cap="flat" cmpd="sng" algn="ctr">
+                      <a:solidFill>
+                        <a:srgbClr val="D9E2EE"/>
+                      </a:solidFill>
+                      <a:prstDash val="solid"/>
+                      <a:round/>
+                      <a:headEnd type="none" w="med" len="med"/>
+                      <a:tailEnd type="none" w="med" len="med"/>
+                    </a:lnL>
+                    <a:lnR w="9525" cap="flat" cmpd="sng" algn="ctr">
+                      <a:solidFill>
+                        <a:srgbClr val="D9E2EE"/>
+                      </a:solidFill>
+                      <a:prstDash val="solid"/>
+                      <a:round/>
+                      <a:headEnd type="none" w="med" len="med"/>
+                      <a:tailEnd type="none" w="med" len="med"/>
+                    </a:lnR>
+                    <a:lnT w="9525" cap="flat" cmpd="sng" algn="ctr">
+                      <a:solidFill>
+                        <a:srgbClr val="D9E2EE"/>
+                      </a:solidFill>
+                      <a:prstDash val="solid"/>
+                      <a:round/>
+                      <a:headEnd type="none" w="med" len="med"/>
+                      <a:tailEnd type="none" w="med" len="med"/>
+                    </a:lnT>
+                    <a:lnB w="9525" cap="flat" cmpd="sng" algn="ctr">
+                      <a:solidFill>
+                        <a:srgbClr val="D9E2EE"/>
+                      </a:solidFill>
+                      <a:prstDash val="solid"/>
+                      <a:round/>
+                      <a:headEnd type="none" w="med" len="med"/>
+                      <a:tailEnd type="none" w="med" len="med"/>
+                    </a:lnB>
+                    <a:solidFill>
+                      <a:srgbClr val="EAF2FD"/>
+                    </a:solidFill>
+                  </a:tcPr>
+                </a:tc>
+                <a:tc>
+                  <a:txBody>
+                    <a:bodyPr/>
+                    <a:lstStyle/>
+                    <a:p>
+                      <a:pPr algn="ctr" indent="0" marL="0">
+                        <a:buNone/>
+                      </a:pPr>
+                      <a:r>
+                        <a:rPr lang="en-US" sz="1200" dirty="0">
+                          <a:solidFill>
+                            <a:srgbClr val="172A3A"/>
+                          </a:solidFill>
+                          <a:latin typeface="微软雅黑" pitchFamily="34" charset="0"/>
+                          <a:ea typeface="微软雅黑" pitchFamily="34" charset="-122"/>
+                          <a:cs typeface="微软雅黑" pitchFamily="34" charset="-120"/>
+                        </a:rPr>
+                        <a:t>0.993</a:t>
+                      </a:r>
+                      <a:endParaRPr lang="en-US" sz="1200" dirty="0">
+                        <a:latin typeface="微软雅黑" charset="0"/>
+                        <a:ea typeface="微软雅黑" charset="0"/>
+                        <a:cs typeface="微软雅黑" charset="0"/>
+                      </a:endParaRPr>
+                    </a:p>
+                  </a:txBody>
+                  <a:tcPr marL="91440" marR="91440" marT="45720" marB="45720" anchor="ctr">
+                    <a:lnL w="9525" cap="flat" cmpd="sng" algn="ctr">
+                      <a:solidFill>
+                        <a:srgbClr val="D9E2EE"/>
+                      </a:solidFill>
+                      <a:prstDash val="solid"/>
+                      <a:round/>
+                      <a:headEnd type="none" w="med" len="med"/>
+                      <a:tailEnd type="none" w="med" len="med"/>
+                    </a:lnL>
+                    <a:lnR w="9525" cap="flat" cmpd="sng" algn="ctr">
+                      <a:solidFill>
+                        <a:srgbClr val="D9E2EE"/>
+                      </a:solidFill>
+                      <a:prstDash val="solid"/>
+                      <a:round/>
+                      <a:headEnd type="none" w="med" len="med"/>
+                      <a:tailEnd type="none" w="med" len="med"/>
+                    </a:lnR>
+                    <a:lnT w="9525" cap="flat" cmpd="sng" algn="ctr">
+                      <a:solidFill>
+                        <a:srgbClr val="D9E2EE"/>
+                      </a:solidFill>
+                      <a:prstDash val="solid"/>
+                      <a:round/>
+                      <a:headEnd type="none" w="med" len="med"/>
+                      <a:tailEnd type="none" w="med" len="med"/>
+                    </a:lnT>
+                    <a:lnB w="9525" cap="flat" cmpd="sng" algn="ctr">
+                      <a:solidFill>
+                        <a:srgbClr val="D9E2EE"/>
+                      </a:solidFill>
+                      <a:prstDash val="solid"/>
+                      <a:round/>
+                      <a:headEnd type="none" w="med" len="med"/>
+                      <a:tailEnd type="none" w="med" len="med"/>
+                    </a:lnB>
+                    <a:solidFill>
+                      <a:srgbClr val="EAF2FD"/>
+                    </a:solidFill>
+                  </a:tcPr>
+                </a:tc>
+                <a:tc>
+                  <a:txBody>
+                    <a:bodyPr/>
+                    <a:lstStyle/>
+                    <a:p>
+                      <a:pPr algn="ctr" indent="0" marL="0">
+                        <a:buNone/>
+                      </a:pPr>
+                      <a:r>
+                        <a:rPr lang="en-US" sz="1200" dirty="0">
+                          <a:solidFill>
+                            <a:srgbClr val="172A3A"/>
+                          </a:solidFill>
+                          <a:latin typeface="微软雅黑" pitchFamily="34" charset="0"/>
+                          <a:ea typeface="微软雅黑" pitchFamily="34" charset="-122"/>
+                          <a:cs typeface="微软雅黑" pitchFamily="34" charset="-120"/>
+                        </a:rPr>
+                        <a:t>0.973</a:t>
+                      </a:r>
+                      <a:endParaRPr lang="en-US" sz="1200" dirty="0">
+                        <a:latin typeface="微软雅黑" charset="0"/>
+                        <a:ea typeface="微软雅黑" charset="0"/>
+                        <a:cs typeface="微软雅黑" charset="0"/>
+                      </a:endParaRPr>
+                    </a:p>
+                  </a:txBody>
+                  <a:tcPr marL="91440" marR="91440" marT="45720" marB="45720" anchor="ctr">
+                    <a:lnL w="9525" cap="flat" cmpd="sng" algn="ctr">
+                      <a:solidFill>
+                        <a:srgbClr val="D9E2EE"/>
+                      </a:solidFill>
+                      <a:prstDash val="solid"/>
+                      <a:round/>
+                      <a:headEnd type="none" w="med" len="med"/>
+                      <a:tailEnd type="none" w="med" len="med"/>
+                    </a:lnL>
+                    <a:lnR w="9525" cap="flat" cmpd="sng" algn="ctr">
+                      <a:solidFill>
+                        <a:srgbClr val="D9E2EE"/>
+                      </a:solidFill>
+                      <a:prstDash val="solid"/>
+                      <a:round/>
+                      <a:headEnd type="none" w="med" len="med"/>
+                      <a:tailEnd type="none" w="med" len="med"/>
+                    </a:lnR>
+                    <a:lnT w="9525" cap="flat" cmpd="sng" algn="ctr">
+                      <a:solidFill>
+                        <a:srgbClr val="D9E2EE"/>
+                      </a:solidFill>
+                      <a:prstDash val="solid"/>
+                      <a:round/>
+                      <a:headEnd type="none" w="med" len="med"/>
+                      <a:tailEnd type="none" w="med" len="med"/>
+                    </a:lnT>
+                    <a:lnB w="9525" cap="flat" cmpd="sng" algn="ctr">
+                      <a:solidFill>
+                        <a:srgbClr val="D9E2EE"/>
+                      </a:solidFill>
+                      <a:prstDash val="solid"/>
+                      <a:round/>
+                      <a:headEnd type="none" w="med" len="med"/>
+                      <a:tailEnd type="none" w="med" len="med"/>
+                    </a:lnB>
+                    <a:solidFill>
+                      <a:srgbClr val="EAF2FD"/>
+                    </a:solidFill>
+                  </a:tcPr>
+                </a:tc>
+                <a:tc>
+                  <a:txBody>
+                    <a:bodyPr/>
+                    <a:lstStyle/>
+                    <a:p>
+                      <a:pPr algn="ctr" indent="0" marL="0">
+                        <a:buNone/>
+                      </a:pPr>
+                      <a:r>
+                        <a:rPr lang="en-US" sz="1200" dirty="0">
+                          <a:solidFill>
+                            <a:srgbClr val="172A3A"/>
+                          </a:solidFill>
+                          <a:latin typeface="微软雅黑" pitchFamily="34" charset="0"/>
+                          <a:ea typeface="微软雅黑" pitchFamily="34" charset="-122"/>
+                          <a:cs typeface="微软雅黑" pitchFamily="34" charset="-120"/>
+                        </a:rPr>
+                        <a:t>4</a:t>
+                      </a:r>
+                      <a:endParaRPr lang="en-US" sz="1200" dirty="0">
+                        <a:latin typeface="微软雅黑" charset="0"/>
+                        <a:ea typeface="微软雅黑" charset="0"/>
+                        <a:cs typeface="微软雅黑" charset="0"/>
+                      </a:endParaRPr>
+                    </a:p>
+                  </a:txBody>
+                  <a:tcPr marL="91440" marR="91440" marT="45720" marB="45720" anchor="ctr">
+                    <a:lnL w="9525" cap="flat" cmpd="sng" algn="ctr">
+                      <a:solidFill>
+                        <a:srgbClr val="D9E2EE"/>
+                      </a:solidFill>
+                      <a:prstDash val="solid"/>
+                      <a:round/>
+                      <a:headEnd type="none" w="med" len="med"/>
+                      <a:tailEnd type="none" w="med" len="med"/>
+                    </a:lnL>
+                    <a:lnR w="9525" cap="flat" cmpd="sng" algn="ctr">
+                      <a:solidFill>
+                        <a:srgbClr val="D9E2EE"/>
+                      </a:solidFill>
+                      <a:prstDash val="solid"/>
+                      <a:round/>
+                      <a:headEnd type="none" w="med" len="med"/>
+                      <a:tailEnd type="none" w="med" len="med"/>
+                    </a:lnR>
+                    <a:lnT w="9525" cap="flat" cmpd="sng" algn="ctr">
+                      <a:solidFill>
+                        <a:srgbClr val="D9E2EE"/>
+                      </a:solidFill>
+                      <a:prstDash val="solid"/>
+                      <a:round/>
+                      <a:headEnd type="none" w="med" len="med"/>
+                      <a:tailEnd type="none" w="med" len="med"/>
+                    </a:lnT>
+                    <a:lnB w="9525" cap="flat" cmpd="sng" algn="ctr">
+                      <a:solidFill>
+                        <a:srgbClr val="D9E2EE"/>
+                      </a:solidFill>
+                      <a:prstDash val="solid"/>
+                      <a:round/>
+                      <a:headEnd type="none" w="med" len="med"/>
+                      <a:tailEnd type="none" w="med" len="med"/>
+                    </a:lnB>
+                    <a:solidFill>
+                      <a:srgbClr val="EAF2FD"/>
+                    </a:solidFill>
+                  </a:tcPr>
+                </a:tc>
+                <a:tc>
+                  <a:txBody>
+                    <a:bodyPr/>
+                    <a:lstStyle/>
+                    <a:p>
+                      <a:pPr algn="ctr" indent="0" marL="0">
+                        <a:buNone/>
+                      </a:pPr>
+                      <a:r>
+                        <a:rPr lang="en-US" sz="1200" dirty="0">
+                          <a:solidFill>
+                            <a:srgbClr val="172A3A"/>
+                          </a:solidFill>
+                          <a:latin typeface="微软雅黑" pitchFamily="34" charset="0"/>
+                          <a:ea typeface="微软雅黑" pitchFamily="34" charset="-122"/>
+                          <a:cs typeface="微软雅黑" pitchFamily="34" charset="-120"/>
+                        </a:rPr>
+                        <a:t>1</a:t>
+                      </a:r>
+                      <a:endParaRPr lang="en-US" sz="1200" dirty="0">
+                        <a:latin typeface="微软雅黑" charset="0"/>
+                        <a:ea typeface="微软雅黑" charset="0"/>
+                        <a:cs typeface="微软雅黑" charset="0"/>
+                      </a:endParaRPr>
+                    </a:p>
+                  </a:txBody>
+                  <a:tcPr marL="91440" marR="91440" marT="45720" marB="45720" anchor="ctr">
+                    <a:lnL w="9525" cap="flat" cmpd="sng" algn="ctr">
+                      <a:solidFill>
+                        <a:srgbClr val="D9E2EE"/>
+                      </a:solidFill>
+                      <a:prstDash val="solid"/>
+                      <a:round/>
+                      <a:headEnd type="none" w="med" len="med"/>
+                      <a:tailEnd type="none" w="med" len="med"/>
+                    </a:lnL>
+                    <a:lnR w="9525" cap="flat" cmpd="sng" algn="ctr">
+                      <a:solidFill>
+                        <a:srgbClr val="D9E2EE"/>
+                      </a:solidFill>
+                      <a:prstDash val="solid"/>
+                      <a:round/>
+                      <a:headEnd type="none" w="med" len="med"/>
+                      <a:tailEnd type="none" w="med" len="med"/>
+                    </a:lnR>
+                    <a:lnT w="9525" cap="flat" cmpd="sng" algn="ctr">
+                      <a:solidFill>
+                        <a:srgbClr val="D9E2EE"/>
+                      </a:solidFill>
+                      <a:prstDash val="solid"/>
+                      <a:round/>
+                      <a:headEnd type="none" w="med" len="med"/>
+                      <a:tailEnd type="none" w="med" len="med"/>
+                    </a:lnT>
+                    <a:lnB w="9525" cap="flat" cmpd="sng" algn="ctr">
+                      <a:solidFill>
+                        <a:srgbClr val="D9E2EE"/>
+                      </a:solidFill>
+                      <a:prstDash val="solid"/>
+                      <a:round/>
+                      <a:headEnd type="none" w="med" len="med"/>
+                      <a:tailEnd type="none" w="med" len="med"/>
+                    </a:lnB>
+                    <a:solidFill>
+                      <a:srgbClr val="EAF2FD"/>
+                    </a:solidFill>
+                  </a:tcPr>
+                </a:tc>
+              </a:tr>
             </a:tbl>
           </a:graphicData>
         </a:graphic>
@@ -4108,12 +5419,12 @@
         </p:nvSpPr>
         <p:spPr>
           <a:xfrm>
-            <a:off x="6720840" y="1371600"/>
-            <a:ext cx="4937760" cy="1060704"/>
+            <a:off x="548640" y="4224528"/>
+            <a:ext cx="6537960" cy="786384"/>
           </a:xfrm>
           <a:prstGeom prst="roundRect">
             <a:avLst>
-              <a:gd name="adj" fmla="val 7759"/>
+              <a:gd name="adj" fmla="val 10465"/>
             </a:avLst>
           </a:prstGeom>
           <a:solidFill>
@@ -4135,8 +5446,8 @@
         </p:nvSpPr>
         <p:spPr>
           <a:xfrm>
-            <a:off x="6903720" y="1453896"/>
-            <a:ext cx="4572000" cy="274320"/>
+            <a:off x="731520" y="4288536"/>
+            <a:ext cx="6217920" cy="256032"/>
           </a:xfrm>
           <a:prstGeom prst="rect">
             <a:avLst/>
@@ -4152,7 +5463,7 @@
               <a:buNone/>
             </a:pPr>
             <a:r>
-              <a:rPr lang="en-US" sz="1300" b="1" dirty="0">
+              <a:rPr lang="en-US" sz="1250" b="1" dirty="0">
                 <a:solidFill>
                   <a:srgbClr val="6096E6"/>
                 </a:solidFill>
@@ -4160,9 +5471,9 @@
                 <a:ea typeface="微软雅黑" pitchFamily="34" charset="-122"/>
                 <a:cs typeface="微软雅黑" pitchFamily="34" charset="-120"/>
               </a:rPr>
-              <a:t>混淆矩阵</a:t>
+              <a:t>迁移学习有效</a:t>
             </a:r>
-            <a:endParaRPr lang="en-US" sz="1300" dirty="0"/>
+            <a:endParaRPr lang="en-US" sz="1250" dirty="0"/>
           </a:p>
         </p:txBody>
       </p:sp>
@@ -4174,8 +5485,8 @@
         </p:nvSpPr>
         <p:spPr>
           <a:xfrm>
-            <a:off x="6903720" y="1737360"/>
-            <a:ext cx="4572000" cy="658368"/>
+            <a:off x="731520" y="4553712"/>
+            <a:ext cx="6217920" cy="438912"/>
           </a:xfrm>
           <a:prstGeom prst="rect">
             <a:avLst/>
@@ -4191,7 +5502,7 @@
               <a:buNone/>
             </a:pPr>
             <a:r>
-              <a:rPr lang="en-US" sz="1150" dirty="0">
+              <a:rPr lang="en-US" sz="1100" dirty="0">
                 <a:solidFill>
                   <a:srgbClr val="172A3A"/>
                 </a:solidFill>
@@ -4199,9 +5510,9 @@
                 <a:ea typeface="微软雅黑" pitchFamily="34" charset="-122"/>
                 <a:cs typeface="微软雅黑" pitchFamily="34" charset="-120"/>
               </a:rPr>
-              <a:t>候选 [[137, 13], [43, 107]] → TN=137、FP=13、FN=43、TP=107</a:t>
+              <a:t>同结构 ResNet18：pretrained 漏检 0 vs scratch 漏检 4——提升来自 ImageNet 预训练，不是网络更大</a:t>
             </a:r>
-            <a:endParaRPr lang="en-US" sz="1150" dirty="0"/>
+            <a:endParaRPr lang="en-US" sz="1100" dirty="0"/>
           </a:p>
         </p:txBody>
       </p:sp>
@@ -4213,12 +5524,12 @@
         </p:nvSpPr>
         <p:spPr>
           <a:xfrm>
-            <a:off x="6720840" y="2578608"/>
-            <a:ext cx="4937760" cy="1060704"/>
+            <a:off x="548640" y="5065776"/>
+            <a:ext cx="6537960" cy="786384"/>
           </a:xfrm>
           <a:prstGeom prst="roundRect">
             <a:avLst>
-              <a:gd name="adj" fmla="val 7759"/>
+              <a:gd name="adj" fmla="val 10465"/>
             </a:avLst>
           </a:prstGeom>
           <a:solidFill>
@@ -4240,8 +5551,8 @@
         </p:nvSpPr>
         <p:spPr>
           <a:xfrm>
-            <a:off x="6903720" y="2660904"/>
-            <a:ext cx="4572000" cy="274320"/>
+            <a:off x="731520" y="5129784"/>
+            <a:ext cx="6217920" cy="256032"/>
           </a:xfrm>
           <a:prstGeom prst="rect">
             <a:avLst/>
@@ -4257,7 +5568,7 @@
               <a:buNone/>
             </a:pPr>
             <a:r>
-              <a:rPr lang="en-US" sz="1300" b="1" dirty="0">
+              <a:rPr lang="en-US" sz="1250" b="1" dirty="0">
                 <a:solidFill>
                   <a:srgbClr val="6096E6"/>
                 </a:solidFill>
@@ -4265,9 +5576,9 @@
                 <a:ea typeface="微软雅黑" pitchFamily="34" charset="-122"/>
                 <a:cs typeface="微软雅黑" pitchFamily="34" charset="-120"/>
               </a:rPr>
-              <a:t>亲手验算</a:t>
+              <a:t>阈值是另一回事</a:t>
             </a:r>
-            <a:endParaRPr lang="en-US" sz="1300" dirty="0"/>
+            <a:endParaRPr lang="en-US" sz="1250" dirty="0"/>
           </a:p>
         </p:txBody>
       </p:sp>
@@ -4279,8 +5590,8 @@
         </p:nvSpPr>
         <p:spPr>
           <a:xfrm>
-            <a:off x="6903720" y="2944368"/>
-            <a:ext cx="4572000" cy="658368"/>
+            <a:off x="731520" y="5394960"/>
+            <a:ext cx="6217920" cy="438912"/>
           </a:xfrm>
           <a:prstGeom prst="rect">
             <a:avLst/>
@@ -4296,7 +5607,7 @@
               <a:buNone/>
             </a:pPr>
             <a:r>
-              <a:rPr lang="en-US" sz="1150" dirty="0">
+              <a:rPr lang="en-US" sz="1100" dirty="0">
                 <a:solidFill>
                   <a:srgbClr val="172A3A"/>
                 </a:solidFill>
@@ -4304,9 +5615,9 @@
                 <a:ea typeface="微软雅黑" pitchFamily="34" charset="-122"/>
                 <a:cs typeface="微软雅黑" pitchFamily="34" charset="-120"/>
               </a:rPr>
-              <a:t>召回率 = 107/150 ≈ 0.713；精确率 = 107/120 ≈ 0.892</a:t>
+              <a:t>验证集选出的 0.9996 在测试集漏检 14 张（recall 0.907），默认 0.5 反而漏检 0——对漏检最贵的业务，0.5 是更好的工作点</a:t>
             </a:r>
-            <a:endParaRPr lang="en-US" sz="1150" dirty="0"/>
+            <a:endParaRPr lang="en-US" sz="1100" dirty="0"/>
           </a:p>
         </p:txBody>
       </p:sp>
@@ -4318,12 +5629,12 @@
         </p:nvSpPr>
         <p:spPr>
           <a:xfrm>
-            <a:off x="6720840" y="3785616"/>
-            <a:ext cx="4937760" cy="1060704"/>
+            <a:off x="548640" y="5907024"/>
+            <a:ext cx="6537960" cy="786384"/>
           </a:xfrm>
           <a:prstGeom prst="roundRect">
             <a:avLst>
-              <a:gd name="adj" fmla="val 7759"/>
+              <a:gd name="adj" fmla="val 10465"/>
             </a:avLst>
           </a:prstGeom>
           <a:solidFill>
@@ -4345,8 +5656,8 @@
         </p:nvSpPr>
         <p:spPr>
           <a:xfrm>
-            <a:off x="6903720" y="3867912"/>
-            <a:ext cx="4572000" cy="274320"/>
+            <a:off x="731520" y="5971032"/>
+            <a:ext cx="6217920" cy="256032"/>
           </a:xfrm>
           <a:prstGeom prst="rect">
             <a:avLst/>
@@ -4362,7 +5673,7 @@
               <a:buNone/>
             </a:pPr>
             <a:r>
-              <a:rPr lang="en-US" sz="1300" b="1" dirty="0">
+              <a:rPr lang="en-US" sz="1250" b="1" dirty="0">
                 <a:solidFill>
                   <a:srgbClr val="6096E6"/>
                 </a:solidFill>
@@ -4370,9 +5681,9 @@
                 <a:ea typeface="微软雅黑" pitchFamily="34" charset="-122"/>
                 <a:cs typeface="微软雅黑" pitchFamily="34" charset="-120"/>
               </a:rPr>
-              <a:t>关键解读</a:t>
+              <a:t>筛查价值</a:t>
             </a:r>
-            <a:endParaRPr lang="en-US" sz="1300" dirty="0"/>
+            <a:endParaRPr lang="en-US" sz="1250" dirty="0"/>
           </a:p>
         </p:txBody>
       </p:sp>
@@ -4384,8 +5695,8 @@
         </p:nvSpPr>
         <p:spPr>
           <a:xfrm>
-            <a:off x="6903720" y="4151376"/>
-            <a:ext cx="4572000" cy="658368"/>
+            <a:off x="731520" y="6236208"/>
+            <a:ext cx="6217920" cy="438912"/>
           </a:xfrm>
           <a:prstGeom prst="rect">
             <a:avLst/>
@@ -4401,7 +5712,7 @@
               <a:buNone/>
             </a:pPr>
             <a:r>
-              <a:rPr lang="en-US" sz="1150" dirty="0">
+              <a:rPr lang="en-US" sz="1100" dirty="0">
                 <a:solidFill>
                   <a:srgbClr val="172A3A"/>
                 </a:solidFill>
@@ -4409,49 +5720,46 @@
                 <a:ea typeface="微软雅黑" pitchFamily="34" charset="-122"/>
                 <a:cs typeface="微软雅黑" pitchFamily="34" charset="-120"/>
               </a:rPr>
-              <a:t>基线全猜 crack 虽召回 1.0 却误报 150 张（没有筛选价值）；CNN 把误报降到 13，代价是 43 张漏检</a:t>
+              <a:t>SmallCNN 漏 43 张 → ResNet18 漏 0 张、误报仅 1；但子集仍有相关图像泄漏风险，不推广到全部 40,000 张</a:t>
             </a:r>
-            <a:endParaRPr lang="en-US" sz="1150" dirty="0"/>
+            <a:endParaRPr lang="en-US" sz="1100" dirty="0"/>
           </a:p>
         </p:txBody>
       </p:sp>
-      <p:sp>
-        <p:nvSpPr>
-          <p:cNvPr id="14" name="Shape 11"/>
+      <p:pic>
+        <p:nvPicPr>
+          <p:cNvPr id="14" name="Image 0" descr="C:/Users/蔡焕新/Documents/GitHub/mikuday0/student-work/day-02-concrete/runs/resnet18_pretrained-validation-recall-threshold.png">    </p:cNvPr>
+          <p:cNvPicPr>
+            <a:picLocks noChangeAspect="1"/>
+          </p:cNvPicPr>
+          <p:nvPr/>
+        </p:nvPicPr>
+        <p:blipFill>
+          <a:blip r:embed="rId1"/>
+          <a:stretch>
+            <a:fillRect/>
+          </a:stretch>
+        </p:blipFill>
+        <p:spPr>
+          <a:xfrm>
+            <a:off x="7726680" y="4297680"/>
+            <a:ext cx="3840480" cy="2194560"/>
+          </a:xfrm>
+          <a:prstGeom prst="rect">
+            <a:avLst/>
+          </a:prstGeom>
+        </p:spPr>
+      </p:pic>
+      <p:sp>
+        <p:nvSpPr>
+          <p:cNvPr id="15" name="Text 11"/>
           <p:cNvSpPr/>
           <p:nvPr/>
         </p:nvSpPr>
         <p:spPr>
           <a:xfrm>
-            <a:off x="6720840" y="4992624"/>
-            <a:ext cx="4937760" cy="1060704"/>
-          </a:xfrm>
-          <a:prstGeom prst="roundRect">
-            <a:avLst>
-              <a:gd name="adj" fmla="val 7759"/>
-            </a:avLst>
-          </a:prstGeom>
-          <a:solidFill>
-            <a:srgbClr val="F5F8FC"/>
-          </a:solidFill>
-          <a:ln w="12700">
-            <a:solidFill>
-              <a:srgbClr val="E4EAF2"/>
-            </a:solidFill>
-            <a:prstDash val="solid"/>
-          </a:ln>
-        </p:spPr>
-      </p:sp>
-      <p:sp>
-        <p:nvSpPr>
-          <p:cNvPr id="15" name="Text 12"/>
-          <p:cNvSpPr/>
-          <p:nvPr/>
-        </p:nvSpPr>
-        <p:spPr>
-          <a:xfrm>
-            <a:off x="6903720" y="5074920"/>
-            <a:ext cx="4572000" cy="274320"/>
+            <a:off x="7726680" y="6528816"/>
+            <a:ext cx="3840480" cy="274320"/>
           </a:xfrm>
           <a:prstGeom prst="rect">
             <a:avLst/>
@@ -4463,60 +5771,21 @@
           <a:bodyPr wrap="square" rtlCol="0" anchor="ctr"/>
           <a:lstStyle/>
           <a:p>
-            <a:pPr indent="0" marL="0">
+            <a:pPr algn="ctr" indent="0" marL="0">
               <a:buNone/>
             </a:pPr>
             <a:r>
-              <a:rPr lang="en-US" sz="1300" b="1" dirty="0">
+              <a:rPr lang="en-US" sz="1050" dirty="0">
                 <a:solidFill>
-                  <a:srgbClr val="6096E6"/>
+                  <a:srgbClr val="5B6B7A"/>
                 </a:solidFill>
                 <a:latin typeface="微软雅黑" pitchFamily="34" charset="0"/>
                 <a:ea typeface="微软雅黑" pitchFamily="34" charset="-122"/>
                 <a:cs typeface="微软雅黑" pitchFamily="34" charset="-120"/>
               </a:rPr>
-              <a:t>错误分布</a:t>
+              <a:t>验证集上的阈值-召回率曲线（只用于选阈值，test 仅评一次）</a:t>
             </a:r>
-            <a:endParaRPr lang="en-US" sz="1300" dirty="0"/>
-          </a:p>
-        </p:txBody>
-      </p:sp>
-      <p:sp>
-        <p:nvSpPr>
-          <p:cNvPr id="16" name="Text 13"/>
-          <p:cNvSpPr/>
-          <p:nvPr/>
-        </p:nvSpPr>
-        <p:spPr>
-          <a:xfrm>
-            <a:off x="6903720" y="5358384"/>
-            <a:ext cx="4572000" cy="658368"/>
-          </a:xfrm>
-          <a:prstGeom prst="rect">
-            <a:avLst/>
-          </a:prstGeom>
-          <a:noFill/>
-          <a:ln/>
-        </p:spPr>
-        <p:txBody>
-          <a:bodyPr wrap="square" rtlCol="0" anchor="t"/>
-          <a:lstStyle/>
-          <a:p>
-            <a:pPr indent="0" marL="0">
-              <a:buNone/>
-            </a:pPr>
-            <a:r>
-              <a:rPr lang="en-US" sz="1150" dirty="0">
-                <a:solidFill>
-                  <a:srgbClr val="172A3A"/>
-                </a:solidFill>
-                <a:latin typeface="微软雅黑" pitchFamily="34" charset="0"/>
-                <a:ea typeface="微软雅黑" pitchFamily="34" charset="-122"/>
-                <a:cs typeface="微软雅黑" pitchFamily="34" charset="-120"/>
-              </a:rPr>
-              <a:t>56 个错误 = 43 漏检 + 13 误报；漏检组平均更亮（0.716 vs 0.607），误报组最暗（0.548）</a:t>
-            </a:r>
-            <a:endParaRPr lang="en-US" sz="1150" dirty="0"/>
+            <a:endParaRPr lang="en-US" sz="1050" dirty="0"/>
           </a:p>
         </p:txBody>
       </p:sp>
@@ -4624,7 +5893,7 @@
                 <a:ea typeface="微软雅黑" pitchFamily="34" charset="-122"/>
                 <a:cs typeface="微软雅黑" pitchFamily="34" charset="-120"/>
               </a:rPr>
-              <a:t>一个真实漏检案例 + 边界 + 下一步（配图均为真实数据）</a:t>
+              <a:t>一个真实漏检案例 + 边界 + 下一步（配图均为真实数据；蓝色小标 = 课程文件里没有的自主内容）</a:t>
             </a:r>
             <a:endParaRPr lang="en-US" sz="1400" dirty="0"/>
           </a:p>
@@ -4821,6 +6090,20 @@
               </a:rPr>
               <a:t>为什么出错</a:t>
             </a:r>
+            <a:pPr indent="0" marL="0">
+              <a:buNone/>
+            </a:pPr>
+            <a:r>
+              <a:rPr lang="en-US" sz="1000" b="1" dirty="0">
+                <a:solidFill>
+                  <a:srgbClr val="6096E6"/>
+                </a:solidFill>
+                <a:latin typeface="微软雅黑" pitchFamily="34" charset="0"/>
+                <a:ea typeface="微软雅黑" pitchFamily="34" charset="-122"/>
+                <a:cs typeface="微软雅黑" pitchFamily="34" charset="-120"/>
+              </a:rPr>
+              <a:t> 自主分析</a:t>
+            </a:r>
             <a:endParaRPr lang="en-US" sz="1500" dirty="0"/>
           </a:p>
         </p:txBody>
@@ -4882,7 +6165,7 @@
                 <a:ea typeface="微软雅黑" pitchFamily="34" charset="-122"/>
                 <a:cs typeface="微软雅黑" pitchFamily="34" charset="-120"/>
               </a:rPr>
-              <a:t>偏亮 + 裂缝对比弱 + 边缘密度低，弱外观信号被当成干净表面</a:t>
+              <a:t>偏亮 + 裂缝对比弱 + 边缘密度低，弱外观信号被当成干净表面（统计自 analyze_errors.py）</a:t>
             </a:r>
             <a:endParaRPr lang="en-US" sz="1150" dirty="0"/>
           </a:p>
@@ -5079,6 +6362,20 @@
               </a:rPr>
               <a:t>下一问题</a:t>
             </a:r>
+            <a:pPr indent="0" marL="0">
+              <a:buNone/>
+            </a:pPr>
+            <a:r>
+              <a:rPr lang="en-US" sz="1000" b="1" dirty="0">
+                <a:solidFill>
+                  <a:srgbClr val="6096E6"/>
+                </a:solidFill>
+                <a:latin typeface="微软雅黑" pitchFamily="34" charset="0"/>
+                <a:ea typeface="微软雅黑" pitchFamily="34" charset="-122"/>
+                <a:cs typeface="微软雅黑" pitchFamily="34" charset="-120"/>
+              </a:rPr>
+              <a:t> 扩展方向</a:t>
+            </a:r>
             <a:endParaRPr lang="en-US" sz="1500" dirty="0"/>
           </a:p>
         </p:txBody>
@@ -5140,7 +6437,7 @@
                 <a:ea typeface="微软雅黑" pitchFamily="34" charset="-122"/>
                 <a:cs typeface="微软雅黑" pitchFamily="34" charset="-120"/>
               </a:rPr>
-              <a:t>人工查看 43 张漏检图确认裂缝；同条件下试更多 epoch，先预测再实验</a:t>
+              <a:t>下一步：Grad-CAM 热力图，看模型注意力在裂缝还是阴影/污渍——直接衔接现有失败案例分析</a:t>
             </a:r>
             <a:endParaRPr lang="en-US" sz="1150" dirty="0"/>
           </a:p>

</xml_diff>